<commit_message>
chore: finalize TV store submission assets
</commit_message>
<xml_diff>
--- a/store-assets/samsung/Nuvio_TV_UI_Description.pptx
+++ b/store-assets/samsung/Nuvio_TV_UI_Description.pptx
@@ -2,19 +2,19 @@
 <file path=ppt/presentation.xml><?xml version="1.0" encoding="utf-8"?>
 <p:presentation xmlns:p="http://schemas.openxmlformats.org/presentationml/2006/main">
   <p:sldMasterIdLst>
-    <p:sldMasterId xmlns:r="http://schemas.openxmlformats.org/officeDocument/2006/relationships" id="2147483648" r:id="R5625584cd71247c5"/>
+    <p:sldMasterId xmlns:r="http://schemas.openxmlformats.org/officeDocument/2006/relationships" id="2147483648" r:id="Rca8f370e9bc147fc"/>
   </p:sldMasterIdLst>
   <p:notesMasterIdLst>
-    <p:notesMasterId xmlns:r="http://schemas.openxmlformats.org/officeDocument/2006/relationships" r:id="Rfded4778124c4198"/>
+    <p:notesMasterId xmlns:r="http://schemas.openxmlformats.org/officeDocument/2006/relationships" r:id="R4e6185bfd7be4980"/>
   </p:notesMasterIdLst>
   <p:sldIdLst>
-    <p:sldId xmlns:r="http://schemas.openxmlformats.org/officeDocument/2006/relationships" id="256" r:id="R371ae30cbdf44853"/>
-    <p:sldId xmlns:r="http://schemas.openxmlformats.org/officeDocument/2006/relationships" id="257" r:id="R5c3de83f399b42d0"/>
-    <p:sldId xmlns:r="http://schemas.openxmlformats.org/officeDocument/2006/relationships" id="258" r:id="R11266fe8967b46d4"/>
-    <p:sldId xmlns:r="http://schemas.openxmlformats.org/officeDocument/2006/relationships" id="259" r:id="R3194e96f464c47e3"/>
-    <p:sldId xmlns:r="http://schemas.openxmlformats.org/officeDocument/2006/relationships" id="260" r:id="Readd34c58dac44e1"/>
-    <p:sldId xmlns:r="http://schemas.openxmlformats.org/officeDocument/2006/relationships" id="261" r:id="Rb6f590b2cdeb4e8c"/>
-    <p:sldId xmlns:r="http://schemas.openxmlformats.org/officeDocument/2006/relationships" id="262" r:id="Ra71c0c4411f34b1f"/>
+    <p:sldId xmlns:r="http://schemas.openxmlformats.org/officeDocument/2006/relationships" id="256" r:id="R3ff134e4ea3d451e"/>
+    <p:sldId xmlns:r="http://schemas.openxmlformats.org/officeDocument/2006/relationships" id="257" r:id="Rcbda80345bc64341"/>
+    <p:sldId xmlns:r="http://schemas.openxmlformats.org/officeDocument/2006/relationships" id="258" r:id="R05f718743b1d4a08"/>
+    <p:sldId xmlns:r="http://schemas.openxmlformats.org/officeDocument/2006/relationships" id="259" r:id="R293d682a84b146b6"/>
+    <p:sldId xmlns:r="http://schemas.openxmlformats.org/officeDocument/2006/relationships" id="260" r:id="R4939b373903d43c4"/>
+    <p:sldId xmlns:r="http://schemas.openxmlformats.org/officeDocument/2006/relationships" id="261" r:id="R21b9b2fc1e1b440a"/>
+    <p:sldId xmlns:r="http://schemas.openxmlformats.org/officeDocument/2006/relationships" id="262" r:id="R61680cd170684cf9"/>
   </p:sldIdLst>
   <p:sldSz cx="12192000" cy="6858000"/>
   <p:notesSz cx="6858000" cy="9144000"/>
@@ -533,12 +533,12 @@
           </a:p>
           <a:p xmlns:a="http://schemas.openxmlformats.org/drawingml/2006/main">
             <a:r>
-              <a:t>Nuvio Android product positioning reference: https://play.google.com/store/apps/details?id=com.nuvio.app</a:t>
-            </a:r>
-          </a:p>
-          <a:p xmlns:a="http://schemas.openxmlformats.org/drawingml/2006/main">
-            <a:r>
-              <a:t>The public listing’s publisher/support identity is not copied here because it does not match the NuvioMedia repository identity; publisher-supplied legal and contact fields remain pending.</a:t>
+              <a:t>Nuvio Android product positioning and publisher/contact reference: https://play.google.com/store/apps/details?id=com.nuvio.app</a:t>
+            </a:r>
+          </a:p>
+          <a:p xmlns:a="http://schemas.openxmlformats.org/drawingml/2006/main">
+            <a:r>
+              <a:t>Store publisher, support and legal fields are copied into the accompanying submission draft at the publisher’s request and still require Seller Office account verification.</a:t>
             </a:r>
           </a:p>
         </p:txBody>
@@ -773,12 +773,12 @@
           </a:p>
           <a:p xmlns:a="http://schemas.openxmlformats.org/drawingml/2006/main">
             <a:r>
-              <a:t>Local screenshot captured from the NuvioTV-Web build at 1920x1080.</a:t>
-            </a:r>
-          </a:p>
-          <a:p xmlns:a="http://schemas.openxmlformats.org/drawingml/2006/main">
-            <a:r>
-              <a:t>Samsung player information and service registration fields: https://developer.samsung.com/tv-seller-office/guides/applications/entering-application-information.html</a:t>
+              <a:t>Local English screenshot captured from the NuvioTV-Web build at 1920x1080.</a:t>
+            </a:r>
+          </a:p>
+          <a:p xmlns:a="http://schemas.openxmlformats.org/drawingml/2006/main">
+            <a:r>
+              <a:t>The screenshot shows the first Appearance screen, including color themes, AMOLED mode, settings style and app language.</a:t>
             </a:r>
           </a:p>
         </p:txBody>
@@ -1016,7 +1016,7 @@
   </p:cSld>
   <p:clrMap bg1="lt1" tx1="dk1" bg2="lt2" tx2="dk2" accent1="accent1" accent2="accent2" accent3="accent3" accent4="accent4" accent5="accent5" accent6="accent6" hlink="hlink" folHlink="folHlink"/>
   <p:sldLayoutIdLst>
-    <p:sldLayoutId xmlns:r="http://schemas.openxmlformats.org/officeDocument/2006/relationships" id="2147483649" r:id="R2bbc04b4e79f4d1a"/>
+    <p:sldLayoutId xmlns:r="http://schemas.openxmlformats.org/officeDocument/2006/relationships" id="2147483649" r:id="Rc6fbf05b6f3c4254"/>
   </p:sldLayoutIdLst>
   <p:txStyles>
     <p:titleStyle>
@@ -1567,7 +1567,7 @@
           <p:cNvPr id="11" name="cover-bg">
             <a:extLst xmlns:a="http://schemas.openxmlformats.org/drawingml/2006/main">
               <a:ext uri="{FF2B5EF4-FFF2-40B4-BE49-F238E27FC236}">
-                <a16:creationId xmlns:a16="http://schemas.microsoft.com/office/drawing/2014/main" id="{570B9547-E8C4-40BC-B12B-63BEBDF25B51}"/>
+                <a16:creationId xmlns:a16="http://schemas.microsoft.com/office/drawing/2014/main" id="{54D06B74-B9DC-45D3-B736-B80C4278657B}"/>
               </a:ext>
             </a:extLst>
           </p:cNvPr>
@@ -1598,7 +1598,7 @@
           <p:cNvPr id="2" name="cover-accent">
             <a:extLst xmlns:a="http://schemas.openxmlformats.org/drawingml/2006/main">
               <a:ext uri="{FF2B5EF4-FFF2-40B4-BE49-F238E27FC236}">
-                <a16:creationId xmlns:a16="http://schemas.microsoft.com/office/drawing/2014/main" id="{17CCD6AD-CBD1-4EAE-AAF1-A68D06C2696B}"/>
+                <a16:creationId xmlns:a16="http://schemas.microsoft.com/office/drawing/2014/main" id="{0E5DBA47-8D61-412F-B97F-3EDAEC739CEB}"/>
               </a:ext>
             </a:extLst>
           </p:cNvPr>
@@ -1633,7 +1633,7 @@
           <p:nvPr/>
         </p:nvPicPr>
         <p:blipFill>
-          <a:blip xmlns:r="http://schemas.openxmlformats.org/officeDocument/2006/relationships" xmlns:a="http://schemas.openxmlformats.org/drawingml/2006/main" r:embed="R34feccdafc454961"/>
+          <a:blip xmlns:r="http://schemas.openxmlformats.org/officeDocument/2006/relationships" xmlns:a="http://schemas.openxmlformats.org/drawingml/2006/main" r:embed="R7f60f49f244e4657"/>
           <a:stretch xmlns:a="http://schemas.openxmlformats.org/drawingml/2006/main"/>
         </p:blipFill>
         <p:spPr>
@@ -1653,7 +1653,7 @@
           <p:cNvPr id="4" name="cover-title">
             <a:extLst xmlns:a="http://schemas.openxmlformats.org/drawingml/2006/main">
               <a:ext uri="{FF2B5EF4-FFF2-40B4-BE49-F238E27FC236}">
-                <a16:creationId xmlns:a16="http://schemas.microsoft.com/office/drawing/2014/main" id="{9C91F40F-C79D-48FA-8489-71BC230C1E22}"/>
+                <a16:creationId xmlns:a16="http://schemas.microsoft.com/office/drawing/2014/main" id="{FFC828BD-3B8A-4497-8CD1-AF5A951D020E}"/>
               </a:ext>
             </a:extLst>
           </p:cNvPr>
@@ -1734,7 +1734,7 @@
           <p:cNvPr id="5" name="cover-subtitle">
             <a:extLst xmlns:a="http://schemas.openxmlformats.org/drawingml/2006/main">
               <a:ext uri="{FF2B5EF4-FFF2-40B4-BE49-F238E27FC236}">
-                <a16:creationId xmlns:a16="http://schemas.microsoft.com/office/drawing/2014/main" id="{850C2803-D0D1-43C0-941B-6AB37AC2937A}"/>
+                <a16:creationId xmlns:a16="http://schemas.microsoft.com/office/drawing/2014/main" id="{49B3F9B6-2E60-448D-8F23-FE494F54ED99}"/>
               </a:ext>
             </a:extLst>
           </p:cNvPr>
@@ -1792,7 +1792,7 @@
           <p:cNvPr id="6" name="cover-description">
             <a:extLst xmlns:a="http://schemas.openxmlformats.org/drawingml/2006/main">
               <a:ext uri="{FF2B5EF4-FFF2-40B4-BE49-F238E27FC236}">
-                <a16:creationId xmlns:a16="http://schemas.microsoft.com/office/drawing/2014/main" id="{9029CF0A-037C-4B56-881B-03509D29171F}"/>
+                <a16:creationId xmlns:a16="http://schemas.microsoft.com/office/drawing/2014/main" id="{22618B18-74E6-4B2D-9D3D-6121F553B568}"/>
               </a:ext>
             </a:extLst>
           </p:cNvPr>
@@ -1877,7 +1877,7 @@
           <p:nvPr/>
         </p:nvPicPr>
         <p:blipFill>
-          <a:blip xmlns:r="http://schemas.openxmlformats.org/officeDocument/2006/relationships" xmlns:a="http://schemas.openxmlformats.org/drawingml/2006/main" r:embed="R2602adbd6bc84b34"/>
+          <a:blip xmlns:r="http://schemas.openxmlformats.org/officeDocument/2006/relationships" xmlns:a="http://schemas.openxmlformats.org/drawingml/2006/main" r:embed="R10a7e94418a24dfb"/>
           <a:stretch xmlns:a="http://schemas.openxmlformats.org/drawingml/2006/main"/>
         </p:blipFill>
         <p:spPr>
@@ -1897,7 +1897,7 @@
           <p:cNvPr id="8" name="cover-meta">
             <a:extLst xmlns:a="http://schemas.openxmlformats.org/drawingml/2006/main">
               <a:ext uri="{FF2B5EF4-FFF2-40B4-BE49-F238E27FC236}">
-                <a16:creationId xmlns:a16="http://schemas.microsoft.com/office/drawing/2014/main" id="{AE015BB5-2424-450C-9377-3198AD90B2F0}"/>
+                <a16:creationId xmlns:a16="http://schemas.microsoft.com/office/drawing/2014/main" id="{84FB1CE3-B490-465A-AF58-622859E1BED2}"/>
               </a:ext>
             </a:extLst>
           </p:cNvPr>
@@ -1978,7 +1978,7 @@
           <p:cNvPr id="9" name="footer-rule">
             <a:extLst xmlns:a="http://schemas.openxmlformats.org/drawingml/2006/main">
               <a:ext uri="{FF2B5EF4-FFF2-40B4-BE49-F238E27FC236}">
-                <a16:creationId xmlns:a16="http://schemas.microsoft.com/office/drawing/2014/main" id="{0C8516AD-45A6-4679-9F48-0D148F7C41FF}"/>
+                <a16:creationId xmlns:a16="http://schemas.microsoft.com/office/drawing/2014/main" id="{562A52A5-8471-493A-BFA6-B2CE9BA1AE79}"/>
               </a:ext>
             </a:extLst>
           </p:cNvPr>
@@ -2009,7 +2009,7 @@
           <p:cNvPr id="10" name="footer">
             <a:extLst xmlns:a="http://schemas.openxmlformats.org/drawingml/2006/main">
               <a:ext uri="{FF2B5EF4-FFF2-40B4-BE49-F238E27FC236}">
-                <a16:creationId xmlns:a16="http://schemas.microsoft.com/office/drawing/2014/main" id="{09D59047-06E8-4EE2-8DB8-AE4B1C9D3B04}"/>
+                <a16:creationId xmlns:a16="http://schemas.microsoft.com/office/drawing/2014/main" id="{F1D742B7-165E-4BED-9F1A-7F1A1878931F}"/>
               </a:ext>
             </a:extLst>
           </p:cNvPr>
@@ -2065,7 +2065,7 @@
     </p:spTree>
     <p:extLst>
       <p:ext uri="{BB962C8B-B14F-4D97-AF65-F5344CB8AC3E}">
-        <p14:creationId xmlns:p14="http://schemas.microsoft.com/office/powerpoint/2010/main" val="1529884248"/>
+        <p14:creationId xmlns:p14="http://schemas.microsoft.com/office/powerpoint/2010/main" val="2112449561"/>
       </p:ext>
     </p:extLst>
   </p:cSld>
@@ -2096,7 +2096,7 @@
           <p:cNvPr id="24" name="eyebrow-2">
             <a:extLst xmlns:a="http://schemas.openxmlformats.org/drawingml/2006/main">
               <a:ext uri="{FF2B5EF4-FFF2-40B4-BE49-F238E27FC236}">
-                <a16:creationId xmlns:a16="http://schemas.microsoft.com/office/drawing/2014/main" id="{88EE3C5F-17F7-4579-B6DF-CA7298212E44}"/>
+                <a16:creationId xmlns:a16="http://schemas.microsoft.com/office/drawing/2014/main" id="{61DFEB2C-6386-4848-8983-DBF8C163912B}"/>
               </a:ext>
             </a:extLst>
           </p:cNvPr>
@@ -2154,7 +2154,7 @@
           <p:cNvPr id="2" name="title-2">
             <a:extLst xmlns:a="http://schemas.openxmlformats.org/drawingml/2006/main">
               <a:ext uri="{FF2B5EF4-FFF2-40B4-BE49-F238E27FC236}">
-                <a16:creationId xmlns:a16="http://schemas.microsoft.com/office/drawing/2014/main" id="{66055869-3608-42BA-8B5B-E1A57BB76566}"/>
+                <a16:creationId xmlns:a16="http://schemas.microsoft.com/office/drawing/2014/main" id="{E59F9352-A94E-483B-B54F-2BA5828815AE}"/>
               </a:ext>
             </a:extLst>
           </p:cNvPr>
@@ -2212,7 +2212,7 @@
           <p:cNvPr id="3" name="page-2">
             <a:extLst xmlns:a="http://schemas.openxmlformats.org/drawingml/2006/main">
               <a:ext uri="{FF2B5EF4-FFF2-40B4-BE49-F238E27FC236}">
-                <a16:creationId xmlns:a16="http://schemas.microsoft.com/office/drawing/2014/main" id="{91AD6E4A-0CA2-4D3C-A3BE-4E67C25D149E}"/>
+                <a16:creationId xmlns:a16="http://schemas.microsoft.com/office/drawing/2014/main" id="{17E0F04D-51D4-4318-B5B4-26B201AE7C0B}"/>
               </a:ext>
             </a:extLst>
           </p:cNvPr>
@@ -2270,7 +2270,7 @@
           <p:cNvPr id="4" name="overview-panel">
             <a:extLst xmlns:a="http://schemas.openxmlformats.org/drawingml/2006/main">
               <a:ext uri="{FF2B5EF4-FFF2-40B4-BE49-F238E27FC236}">
-                <a16:creationId xmlns:a16="http://schemas.microsoft.com/office/drawing/2014/main" id="{1736CB40-EEE9-45E5-B43D-E84916F9AE4B}"/>
+                <a16:creationId xmlns:a16="http://schemas.microsoft.com/office/drawing/2014/main" id="{13698FD1-B966-4D18-8317-67CF1F4B4E78}"/>
               </a:ext>
             </a:extLst>
           </p:cNvPr>
@@ -2305,7 +2305,7 @@
           <p:cNvPr id="5" name="overview-heading">
             <a:extLst xmlns:a="http://schemas.openxmlformats.org/drawingml/2006/main">
               <a:ext uri="{FF2B5EF4-FFF2-40B4-BE49-F238E27FC236}">
-                <a16:creationId xmlns:a16="http://schemas.microsoft.com/office/drawing/2014/main" id="{A6E40B43-CFCC-4DA3-BCEC-89A6FC2CBD6D}"/>
+                <a16:creationId xmlns:a16="http://schemas.microsoft.com/office/drawing/2014/main" id="{837A0DDB-3BD2-4D4D-8B11-9A7313BA72A0}"/>
               </a:ext>
             </a:extLst>
           </p:cNvPr>
@@ -2363,7 +2363,7 @@
           <p:cNvPr id="6" name="overview-body">
             <a:extLst xmlns:a="http://schemas.openxmlformats.org/drawingml/2006/main">
               <a:ext uri="{FF2B5EF4-FFF2-40B4-BE49-F238E27FC236}">
-                <a16:creationId xmlns:a16="http://schemas.microsoft.com/office/drawing/2014/main" id="{E686AEE7-F02C-495A-AFD2-D1C47B299D6E}"/>
+                <a16:creationId xmlns:a16="http://schemas.microsoft.com/office/drawing/2014/main" id="{50754B3A-C45E-437E-86ED-6207DDB4C57A}"/>
               </a:ext>
             </a:extLst>
           </p:cNvPr>
@@ -2421,7 +2421,7 @@
           <p:cNvPr id="7" name="overview-disclosure">
             <a:extLst xmlns:a="http://schemas.openxmlformats.org/drawingml/2006/main">
               <a:ext uri="{FF2B5EF4-FFF2-40B4-BE49-F238E27FC236}">
-                <a16:creationId xmlns:a16="http://schemas.microsoft.com/office/drawing/2014/main" id="{E4AC5FA6-6E57-4E1F-8B21-F1DAAD485539}"/>
+                <a16:creationId xmlns:a16="http://schemas.microsoft.com/office/drawing/2014/main" id="{03830D53-FF19-4E3B-A26D-4FC5271B9250}"/>
               </a:ext>
             </a:extLst>
           </p:cNvPr>
@@ -2479,7 +2479,7 @@
           <p:cNvPr id="8" name="nav-panel">
             <a:extLst xmlns:a="http://schemas.openxmlformats.org/drawingml/2006/main">
               <a:ext uri="{FF2B5EF4-FFF2-40B4-BE49-F238E27FC236}">
-                <a16:creationId xmlns:a16="http://schemas.microsoft.com/office/drawing/2014/main" id="{1D015107-B77B-484B-B30E-E9F188EA0173}"/>
+                <a16:creationId xmlns:a16="http://schemas.microsoft.com/office/drawing/2014/main" id="{AF99BDD4-AA13-490F-94DA-D4C79C506E15}"/>
               </a:ext>
             </a:extLst>
           </p:cNvPr>
@@ -2514,7 +2514,7 @@
           <p:cNvPr id="9" name="nav-heading">
             <a:extLst xmlns:a="http://schemas.openxmlformats.org/drawingml/2006/main">
               <a:ext uri="{FF2B5EF4-FFF2-40B4-BE49-F238E27FC236}">
-                <a16:creationId xmlns:a16="http://schemas.microsoft.com/office/drawing/2014/main" id="{FFEC2514-5C1C-47AF-A28F-3068E7CB9471}"/>
+                <a16:creationId xmlns:a16="http://schemas.microsoft.com/office/drawing/2014/main" id="{2F4A7221-4B5C-487D-98FB-4C0079F2A9E7}"/>
               </a:ext>
             </a:extLst>
           </p:cNvPr>
@@ -2572,7 +2572,7 @@
           <p:cNvPr id="10" name="nav-chip-0">
             <a:extLst xmlns:a="http://schemas.openxmlformats.org/drawingml/2006/main">
               <a:ext uri="{FF2B5EF4-FFF2-40B4-BE49-F238E27FC236}">
-                <a16:creationId xmlns:a16="http://schemas.microsoft.com/office/drawing/2014/main" id="{2EED562C-A256-47FE-B6E5-39F699FB4A2E}"/>
+                <a16:creationId xmlns:a16="http://schemas.microsoft.com/office/drawing/2014/main" id="{3750B271-E0FB-4FB8-950B-F5AC53D85F97}"/>
               </a:ext>
             </a:extLst>
           </p:cNvPr>
@@ -2605,7 +2605,7 @@
           <p:cNvPr id="11" name="nav-label-0">
             <a:extLst xmlns:a="http://schemas.openxmlformats.org/drawingml/2006/main">
               <a:ext uri="{FF2B5EF4-FFF2-40B4-BE49-F238E27FC236}">
-                <a16:creationId xmlns:a16="http://schemas.microsoft.com/office/drawing/2014/main" id="{529BA5C5-125C-4AF1-8821-74A86A1C07A2}"/>
+                <a16:creationId xmlns:a16="http://schemas.microsoft.com/office/drawing/2014/main" id="{4A20BA97-E6A0-4FB8-A375-0BD7430EFA5C}"/>
               </a:ext>
             </a:extLst>
           </p:cNvPr>
@@ -2663,7 +2663,7 @@
           <p:cNvPr id="12" name="nav-value-0">
             <a:extLst xmlns:a="http://schemas.openxmlformats.org/drawingml/2006/main">
               <a:ext uri="{FF2B5EF4-FFF2-40B4-BE49-F238E27FC236}">
-                <a16:creationId xmlns:a16="http://schemas.microsoft.com/office/drawing/2014/main" id="{3E08270F-59AB-491C-B67B-8682B3450854}"/>
+                <a16:creationId xmlns:a16="http://schemas.microsoft.com/office/drawing/2014/main" id="{208D926C-E808-4999-9B28-FFD0C7E2344A}"/>
               </a:ext>
             </a:extLst>
           </p:cNvPr>
@@ -2721,7 +2721,7 @@
           <p:cNvPr id="13" name="nav-chip-1">
             <a:extLst xmlns:a="http://schemas.openxmlformats.org/drawingml/2006/main">
               <a:ext uri="{FF2B5EF4-FFF2-40B4-BE49-F238E27FC236}">
-                <a16:creationId xmlns:a16="http://schemas.microsoft.com/office/drawing/2014/main" id="{D50CD6F2-65A9-46ED-8CF0-052E4C69E319}"/>
+                <a16:creationId xmlns:a16="http://schemas.microsoft.com/office/drawing/2014/main" id="{8B1691BB-1BE5-40AE-A267-43FF1F122F78}"/>
               </a:ext>
             </a:extLst>
           </p:cNvPr>
@@ -2754,7 +2754,7 @@
           <p:cNvPr id="14" name="nav-label-1">
             <a:extLst xmlns:a="http://schemas.openxmlformats.org/drawingml/2006/main">
               <a:ext uri="{FF2B5EF4-FFF2-40B4-BE49-F238E27FC236}">
-                <a16:creationId xmlns:a16="http://schemas.microsoft.com/office/drawing/2014/main" id="{00BDA35E-AA11-4F4B-8B44-7E175BC7BCD5}"/>
+                <a16:creationId xmlns:a16="http://schemas.microsoft.com/office/drawing/2014/main" id="{1A4AD2B9-53C1-4C98-B55C-99021C9E181B}"/>
               </a:ext>
             </a:extLst>
           </p:cNvPr>
@@ -2802,7 +2802,7 @@
                 <a:ea typeface="Helvetica Neue"/>
                 <a:cs typeface="Helvetica Neue"/>
               </a:rPr>
-              <a:t>CERCA</a:t>
+              <a:t>SEARCH</a:t>
             </a:r>
           </a:p>
         </p:txBody>
@@ -2812,7 +2812,7 @@
           <p:cNvPr id="15" name="nav-value-1">
             <a:extLst xmlns:a="http://schemas.openxmlformats.org/drawingml/2006/main">
               <a:ext uri="{FF2B5EF4-FFF2-40B4-BE49-F238E27FC236}">
-                <a16:creationId xmlns:a16="http://schemas.microsoft.com/office/drawing/2014/main" id="{31B8A23A-7BB5-442A-A5A4-1C0BB98F40DE}"/>
+                <a16:creationId xmlns:a16="http://schemas.microsoft.com/office/drawing/2014/main" id="{022450F9-0EC6-4A86-82C2-13C1F1ABEA79}"/>
               </a:ext>
             </a:extLst>
           </p:cNvPr>
@@ -2870,7 +2870,7 @@
           <p:cNvPr id="16" name="nav-chip-2">
             <a:extLst xmlns:a="http://schemas.openxmlformats.org/drawingml/2006/main">
               <a:ext uri="{FF2B5EF4-FFF2-40B4-BE49-F238E27FC236}">
-                <a16:creationId xmlns:a16="http://schemas.microsoft.com/office/drawing/2014/main" id="{2764611C-B067-4954-A575-EEBF780B9FF0}"/>
+                <a16:creationId xmlns:a16="http://schemas.microsoft.com/office/drawing/2014/main" id="{0F7EEA3D-E913-4855-8593-4A44E88ED80C}"/>
               </a:ext>
             </a:extLst>
           </p:cNvPr>
@@ -2903,7 +2903,7 @@
           <p:cNvPr id="17" name="nav-label-2">
             <a:extLst xmlns:a="http://schemas.openxmlformats.org/drawingml/2006/main">
               <a:ext uri="{FF2B5EF4-FFF2-40B4-BE49-F238E27FC236}">
-                <a16:creationId xmlns:a16="http://schemas.microsoft.com/office/drawing/2014/main" id="{FA954E9B-4A68-4915-A9F6-DB12CA6F2A27}"/>
+                <a16:creationId xmlns:a16="http://schemas.microsoft.com/office/drawing/2014/main" id="{D1A29BD6-7A0B-466E-B0DC-20A1073D6B8B}"/>
               </a:ext>
             </a:extLst>
           </p:cNvPr>
@@ -2951,7 +2951,7 @@
                 <a:ea typeface="Helvetica Neue"/>
                 <a:cs typeface="Helvetica Neue"/>
               </a:rPr>
-              <a:t>LIBRERIA</a:t>
+              <a:t>LIBRARY</a:t>
             </a:r>
           </a:p>
         </p:txBody>
@@ -2961,7 +2961,7 @@
           <p:cNvPr id="18" name="nav-value-2">
             <a:extLst xmlns:a="http://schemas.openxmlformats.org/drawingml/2006/main">
               <a:ext uri="{FF2B5EF4-FFF2-40B4-BE49-F238E27FC236}">
-                <a16:creationId xmlns:a16="http://schemas.microsoft.com/office/drawing/2014/main" id="{D335CA60-22BE-461E-8A51-808CA5C37F54}"/>
+                <a16:creationId xmlns:a16="http://schemas.microsoft.com/office/drawing/2014/main" id="{C13F4220-8394-4655-A57A-72A63759CF2D}"/>
               </a:ext>
             </a:extLst>
           </p:cNvPr>
@@ -3019,7 +3019,7 @@
           <p:cNvPr id="19" name="nav-chip-3">
             <a:extLst xmlns:a="http://schemas.openxmlformats.org/drawingml/2006/main">
               <a:ext uri="{FF2B5EF4-FFF2-40B4-BE49-F238E27FC236}">
-                <a16:creationId xmlns:a16="http://schemas.microsoft.com/office/drawing/2014/main" id="{AE1D57C2-AF7D-473E-BAB8-36942AE40C75}"/>
+                <a16:creationId xmlns:a16="http://schemas.microsoft.com/office/drawing/2014/main" id="{F3AABF13-223C-4B25-B4D4-3C12F480AB8E}"/>
               </a:ext>
             </a:extLst>
           </p:cNvPr>
@@ -3052,7 +3052,7 @@
           <p:cNvPr id="20" name="nav-label-3">
             <a:extLst xmlns:a="http://schemas.openxmlformats.org/drawingml/2006/main">
               <a:ext uri="{FF2B5EF4-FFF2-40B4-BE49-F238E27FC236}">
-                <a16:creationId xmlns:a16="http://schemas.microsoft.com/office/drawing/2014/main" id="{21EDB3E1-A9B9-4AF5-B198-80E56E657A8D}"/>
+                <a16:creationId xmlns:a16="http://schemas.microsoft.com/office/drawing/2014/main" id="{2EDFFC0A-2F85-4584-9837-4DE3E16A1572}"/>
               </a:ext>
             </a:extLst>
           </p:cNvPr>
@@ -3100,7 +3100,7 @@
                 <a:ea typeface="Helvetica Neue"/>
                 <a:cs typeface="Helvetica Neue"/>
               </a:rPr>
-              <a:t>IMPOSTAZIONI</a:t>
+              <a:t>SETTINGS</a:t>
             </a:r>
           </a:p>
         </p:txBody>
@@ -3110,7 +3110,7 @@
           <p:cNvPr id="21" name="nav-value-3">
             <a:extLst xmlns:a="http://schemas.openxmlformats.org/drawingml/2006/main">
               <a:ext uri="{FF2B5EF4-FFF2-40B4-BE49-F238E27FC236}">
-                <a16:creationId xmlns:a16="http://schemas.microsoft.com/office/drawing/2014/main" id="{64B57F8C-801A-4918-BB33-D42520721FC1}"/>
+                <a16:creationId xmlns:a16="http://schemas.microsoft.com/office/drawing/2014/main" id="{1041EA2F-B459-4305-87F5-02DA59113F37}"/>
               </a:ext>
             </a:extLst>
           </p:cNvPr>
@@ -3168,7 +3168,7 @@
           <p:cNvPr id="22" name="footer-rule">
             <a:extLst xmlns:a="http://schemas.openxmlformats.org/drawingml/2006/main">
               <a:ext uri="{FF2B5EF4-FFF2-40B4-BE49-F238E27FC236}">
-                <a16:creationId xmlns:a16="http://schemas.microsoft.com/office/drawing/2014/main" id="{E37B886D-337B-4258-8380-5118438DBDDB}"/>
+                <a16:creationId xmlns:a16="http://schemas.microsoft.com/office/drawing/2014/main" id="{7BB2DE43-7DD5-413D-A9F6-4CBC4DAB5A22}"/>
               </a:ext>
             </a:extLst>
           </p:cNvPr>
@@ -3199,7 +3199,7 @@
           <p:cNvPr id="23" name="footer">
             <a:extLst xmlns:a="http://schemas.openxmlformats.org/drawingml/2006/main">
               <a:ext uri="{FF2B5EF4-FFF2-40B4-BE49-F238E27FC236}">
-                <a16:creationId xmlns:a16="http://schemas.microsoft.com/office/drawing/2014/main" id="{3965CE6C-D501-4A26-A42A-381B25D901B7}"/>
+                <a16:creationId xmlns:a16="http://schemas.microsoft.com/office/drawing/2014/main" id="{539E50AF-1602-4FFA-B861-6AC9C2469E65}"/>
               </a:ext>
             </a:extLst>
           </p:cNvPr>
@@ -3255,7 +3255,7 @@
     </p:spTree>
     <p:extLst>
       <p:ext uri="{BB962C8B-B14F-4D97-AF65-F5344CB8AC3E}">
-        <p14:creationId xmlns:p14="http://schemas.microsoft.com/office/powerpoint/2010/main" val="1366970227"/>
+        <p14:creationId xmlns:p14="http://schemas.microsoft.com/office/powerpoint/2010/main" val="1218163662"/>
       </p:ext>
     </p:extLst>
   </p:cSld>
@@ -3286,7 +3286,7 @@
           <p:cNvPr id="17" name="eyebrow-3">
             <a:extLst xmlns:a="http://schemas.openxmlformats.org/drawingml/2006/main">
               <a:ext uri="{FF2B5EF4-FFF2-40B4-BE49-F238E27FC236}">
-                <a16:creationId xmlns:a16="http://schemas.microsoft.com/office/drawing/2014/main" id="{4619617E-ECC7-4EDB-88DF-EF56765525C3}"/>
+                <a16:creationId xmlns:a16="http://schemas.microsoft.com/office/drawing/2014/main" id="{1ACAF525-8BB1-4F48-B7F3-CA5759F38D59}"/>
               </a:ext>
             </a:extLst>
           </p:cNvPr>
@@ -3344,7 +3344,7 @@
           <p:cNvPr id="2" name="title-3">
             <a:extLst xmlns:a="http://schemas.openxmlformats.org/drawingml/2006/main">
               <a:ext uri="{FF2B5EF4-FFF2-40B4-BE49-F238E27FC236}">
-                <a16:creationId xmlns:a16="http://schemas.microsoft.com/office/drawing/2014/main" id="{E4EA1314-1076-4EBE-A0A4-A4ADD4147115}"/>
+                <a16:creationId xmlns:a16="http://schemas.microsoft.com/office/drawing/2014/main" id="{FE29D031-DAE9-4C22-9248-4F4138F7478A}"/>
               </a:ext>
             </a:extLst>
           </p:cNvPr>
@@ -3402,7 +3402,7 @@
           <p:cNvPr id="3" name="page-3">
             <a:extLst xmlns:a="http://schemas.openxmlformats.org/drawingml/2006/main">
               <a:ext uri="{FF2B5EF4-FFF2-40B4-BE49-F238E27FC236}">
-                <a16:creationId xmlns:a16="http://schemas.microsoft.com/office/drawing/2014/main" id="{F147FD58-CB84-4FB6-80C2-F3C33D0EA0D1}"/>
+                <a16:creationId xmlns:a16="http://schemas.microsoft.com/office/drawing/2014/main" id="{6B422708-53E4-4451-AC8D-C8814499A4D3}"/>
               </a:ext>
             </a:extLst>
           </p:cNvPr>
@@ -3460,7 +3460,7 @@
           <p:cNvPr id="4" name="home-image-frame">
             <a:extLst xmlns:a="http://schemas.openxmlformats.org/drawingml/2006/main">
               <a:ext uri="{FF2B5EF4-FFF2-40B4-BE49-F238E27FC236}">
-                <a16:creationId xmlns:a16="http://schemas.microsoft.com/office/drawing/2014/main" id="{F1E6CC33-0DF2-4932-9930-EEC1D45F612D}"/>
+                <a16:creationId xmlns:a16="http://schemas.microsoft.com/office/drawing/2014/main" id="{C495A961-AC1F-4C5A-BA52-CAD941E73DB3}"/>
               </a:ext>
             </a:extLst>
           </p:cNvPr>
@@ -3499,8 +3499,8 @@
           <p:nvPr/>
         </p:nvPicPr>
         <p:blipFill>
-          <a:blip xmlns:r="http://schemas.openxmlformats.org/officeDocument/2006/relationships" xmlns:a="http://schemas.openxmlformats.org/drawingml/2006/main" r:embed="Rae41a51027554130"/>
-          <a:srcRect xmlns:a="http://schemas.openxmlformats.org/drawingml/2006/main" l="0" t="550" r="0" b="550"/>
+          <a:blip xmlns:r="http://schemas.openxmlformats.org/officeDocument/2006/relationships" xmlns:a="http://schemas.openxmlformats.org/drawingml/2006/main" r:embed="R3cf93e5f1e24434b"/>
+          <a:srcRect xmlns:a="http://schemas.openxmlformats.org/drawingml/2006/main" l="0" t="56" r="0" b="56"/>
           <a:stretch xmlns:a="http://schemas.openxmlformats.org/drawingml/2006/main">
             <a:fillRect l="0" t="0" r="0" b="0"/>
           </a:stretch>
@@ -3522,7 +3522,7 @@
           <p:cNvPr id="6" name="home-caption">
             <a:extLst xmlns:a="http://schemas.openxmlformats.org/drawingml/2006/main">
               <a:ext uri="{FF2B5EF4-FFF2-40B4-BE49-F238E27FC236}">
-                <a16:creationId xmlns:a16="http://schemas.microsoft.com/office/drawing/2014/main" id="{746404C7-ACA9-4986-AF04-56DF47A70648}"/>
+                <a16:creationId xmlns:a16="http://schemas.microsoft.com/office/drawing/2014/main" id="{C7B66BE2-0D69-43FE-AF9A-36C450A536C1}"/>
               </a:ext>
             </a:extLst>
           </p:cNvPr>
@@ -3580,7 +3580,7 @@
           <p:cNvPr id="7" name="label-194">
             <a:extLst xmlns:a="http://schemas.openxmlformats.org/drawingml/2006/main">
               <a:ext uri="{FF2B5EF4-FFF2-40B4-BE49-F238E27FC236}">
-                <a16:creationId xmlns:a16="http://schemas.microsoft.com/office/drawing/2014/main" id="{F6E6C211-A22D-427F-B4E7-8AEB4F8180BC}"/>
+                <a16:creationId xmlns:a16="http://schemas.microsoft.com/office/drawing/2014/main" id="{F1E415E6-03CF-42C8-9E59-6CD5EBEE458F}"/>
               </a:ext>
             </a:extLst>
           </p:cNvPr>
@@ -3638,7 +3638,7 @@
           <p:cNvPr id="8" name="value-194">
             <a:extLst xmlns:a="http://schemas.openxmlformats.org/drawingml/2006/main">
               <a:ext uri="{FF2B5EF4-FFF2-40B4-BE49-F238E27FC236}">
-                <a16:creationId xmlns:a16="http://schemas.microsoft.com/office/drawing/2014/main" id="{8BDB78BF-0F25-4518-A511-DE1F0D22C055}"/>
+                <a16:creationId xmlns:a16="http://schemas.microsoft.com/office/drawing/2014/main" id="{81DA145C-E2F9-407C-AC16-B81938C2E2C6}"/>
               </a:ext>
             </a:extLst>
           </p:cNvPr>
@@ -3696,7 +3696,7 @@
           <p:cNvPr id="9" name="label-300">
             <a:extLst xmlns:a="http://schemas.openxmlformats.org/drawingml/2006/main">
               <a:ext uri="{FF2B5EF4-FFF2-40B4-BE49-F238E27FC236}">
-                <a16:creationId xmlns:a16="http://schemas.microsoft.com/office/drawing/2014/main" id="{0F909BCB-7B32-4DAB-888F-CC0536A45FC1}"/>
+                <a16:creationId xmlns:a16="http://schemas.microsoft.com/office/drawing/2014/main" id="{D88240F5-0BA0-43F1-AD66-8867A00A6859}"/>
               </a:ext>
             </a:extLst>
           </p:cNvPr>
@@ -3754,7 +3754,7 @@
           <p:cNvPr id="10" name="value-300">
             <a:extLst xmlns:a="http://schemas.openxmlformats.org/drawingml/2006/main">
               <a:ext uri="{FF2B5EF4-FFF2-40B4-BE49-F238E27FC236}">
-                <a16:creationId xmlns:a16="http://schemas.microsoft.com/office/drawing/2014/main" id="{A7B7E5B2-E59A-478D-898F-A82D6019201F}"/>
+                <a16:creationId xmlns:a16="http://schemas.microsoft.com/office/drawing/2014/main" id="{406CF75E-D7D3-4BC6-A09D-2A7BE55D1F27}"/>
               </a:ext>
             </a:extLst>
           </p:cNvPr>
@@ -3812,7 +3812,7 @@
           <p:cNvPr id="11" name="label-406">
             <a:extLst xmlns:a="http://schemas.openxmlformats.org/drawingml/2006/main">
               <a:ext uri="{FF2B5EF4-FFF2-40B4-BE49-F238E27FC236}">
-                <a16:creationId xmlns:a16="http://schemas.microsoft.com/office/drawing/2014/main" id="{5BA9CC95-4635-43DF-A3BE-22366FD52358}"/>
+                <a16:creationId xmlns:a16="http://schemas.microsoft.com/office/drawing/2014/main" id="{FAD24464-4533-4464-BDBC-CF6FE271171A}"/>
               </a:ext>
             </a:extLst>
           </p:cNvPr>
@@ -3870,7 +3870,7 @@
           <p:cNvPr id="12" name="value-406">
             <a:extLst xmlns:a="http://schemas.openxmlformats.org/drawingml/2006/main">
               <a:ext uri="{FF2B5EF4-FFF2-40B4-BE49-F238E27FC236}">
-                <a16:creationId xmlns:a16="http://schemas.microsoft.com/office/drawing/2014/main" id="{B419F7C9-D0BF-47E2-9686-BB12B24F645F}"/>
+                <a16:creationId xmlns:a16="http://schemas.microsoft.com/office/drawing/2014/main" id="{967C546E-DBF6-490E-A865-7338B3385373}"/>
               </a:ext>
             </a:extLst>
           </p:cNvPr>
@@ -3928,7 +3928,7 @@
           <p:cNvPr id="13" name="label-512">
             <a:extLst xmlns:a="http://schemas.openxmlformats.org/drawingml/2006/main">
               <a:ext uri="{FF2B5EF4-FFF2-40B4-BE49-F238E27FC236}">
-                <a16:creationId xmlns:a16="http://schemas.microsoft.com/office/drawing/2014/main" id="{C3437295-1A54-4E54-969C-B0BCB70D06AD}"/>
+                <a16:creationId xmlns:a16="http://schemas.microsoft.com/office/drawing/2014/main" id="{60E7C92A-7B7C-440C-8F32-7FF41270612D}"/>
               </a:ext>
             </a:extLst>
           </p:cNvPr>
@@ -3986,7 +3986,7 @@
           <p:cNvPr id="14" name="value-512">
             <a:extLst xmlns:a="http://schemas.openxmlformats.org/drawingml/2006/main">
               <a:ext uri="{FF2B5EF4-FFF2-40B4-BE49-F238E27FC236}">
-                <a16:creationId xmlns:a16="http://schemas.microsoft.com/office/drawing/2014/main" id="{10AB8144-5F20-41E9-9410-DF951FE56F84}"/>
+                <a16:creationId xmlns:a16="http://schemas.microsoft.com/office/drawing/2014/main" id="{BFFEF8DB-19CA-4E97-B9E5-BEEE45751A99}"/>
               </a:ext>
             </a:extLst>
           </p:cNvPr>
@@ -4044,7 +4044,7 @@
           <p:cNvPr id="15" name="footer-rule">
             <a:extLst xmlns:a="http://schemas.openxmlformats.org/drawingml/2006/main">
               <a:ext uri="{FF2B5EF4-FFF2-40B4-BE49-F238E27FC236}">
-                <a16:creationId xmlns:a16="http://schemas.microsoft.com/office/drawing/2014/main" id="{11BA0BA6-8D95-4824-B410-947B797C04CC}"/>
+                <a16:creationId xmlns:a16="http://schemas.microsoft.com/office/drawing/2014/main" id="{FEFAB08C-E83F-4815-90CC-9398A6DD6C00}"/>
               </a:ext>
             </a:extLst>
           </p:cNvPr>
@@ -4075,7 +4075,7 @@
           <p:cNvPr id="16" name="footer">
             <a:extLst xmlns:a="http://schemas.openxmlformats.org/drawingml/2006/main">
               <a:ext uri="{FF2B5EF4-FFF2-40B4-BE49-F238E27FC236}">
-                <a16:creationId xmlns:a16="http://schemas.microsoft.com/office/drawing/2014/main" id="{3A894BCD-1FDF-4215-945F-D1E5F29D2F90}"/>
+                <a16:creationId xmlns:a16="http://schemas.microsoft.com/office/drawing/2014/main" id="{014851C5-0709-41D4-9907-B1CAB4E1D7A8}"/>
               </a:ext>
             </a:extLst>
           </p:cNvPr>
@@ -4131,7 +4131,7 @@
     </p:spTree>
     <p:extLst>
       <p:ext uri="{BB962C8B-B14F-4D97-AF65-F5344CB8AC3E}">
-        <p14:creationId xmlns:p14="http://schemas.microsoft.com/office/powerpoint/2010/main" val="1221046404"/>
+        <p14:creationId xmlns:p14="http://schemas.microsoft.com/office/powerpoint/2010/main" val="1504937688"/>
       </p:ext>
     </p:extLst>
   </p:cSld>
@@ -4162,7 +4162,7 @@
           <p:cNvPr id="17" name="eyebrow-4">
             <a:extLst xmlns:a="http://schemas.openxmlformats.org/drawingml/2006/main">
               <a:ext uri="{FF2B5EF4-FFF2-40B4-BE49-F238E27FC236}">
-                <a16:creationId xmlns:a16="http://schemas.microsoft.com/office/drawing/2014/main" id="{E5B2ED59-2440-4254-81D5-0268F9000EBC}"/>
+                <a16:creationId xmlns:a16="http://schemas.microsoft.com/office/drawing/2014/main" id="{44A591E5-D178-4E42-B3B6-ABCC80870B31}"/>
               </a:ext>
             </a:extLst>
           </p:cNvPr>
@@ -4220,7 +4220,7 @@
           <p:cNvPr id="2" name="title-4">
             <a:extLst xmlns:a="http://schemas.openxmlformats.org/drawingml/2006/main">
               <a:ext uri="{FF2B5EF4-FFF2-40B4-BE49-F238E27FC236}">
-                <a16:creationId xmlns:a16="http://schemas.microsoft.com/office/drawing/2014/main" id="{00D476B9-E51E-478A-9986-5F9B0EF108C0}"/>
+                <a16:creationId xmlns:a16="http://schemas.microsoft.com/office/drawing/2014/main" id="{55085040-493C-42EC-BA54-F4ECA232514F}"/>
               </a:ext>
             </a:extLst>
           </p:cNvPr>
@@ -4278,7 +4278,7 @@
           <p:cNvPr id="3" name="page-4">
             <a:extLst xmlns:a="http://schemas.openxmlformats.org/drawingml/2006/main">
               <a:ext uri="{FF2B5EF4-FFF2-40B4-BE49-F238E27FC236}">
-                <a16:creationId xmlns:a16="http://schemas.microsoft.com/office/drawing/2014/main" id="{917AFD6C-E959-4AB4-BEA9-CB4059B75810}"/>
+                <a16:creationId xmlns:a16="http://schemas.microsoft.com/office/drawing/2014/main" id="{A23DDD3E-57DD-4623-8309-56CE4B4CF00E}"/>
               </a:ext>
             </a:extLst>
           </p:cNvPr>
@@ -4336,7 +4336,7 @@
           <p:cNvPr id="4" name="search-image-frame">
             <a:extLst xmlns:a="http://schemas.openxmlformats.org/drawingml/2006/main">
               <a:ext uri="{FF2B5EF4-FFF2-40B4-BE49-F238E27FC236}">
-                <a16:creationId xmlns:a16="http://schemas.microsoft.com/office/drawing/2014/main" id="{42AAEE81-9784-4388-88F1-01AF37201E25}"/>
+                <a16:creationId xmlns:a16="http://schemas.microsoft.com/office/drawing/2014/main" id="{9C054648-2091-4640-84D0-78E03FBC8332}"/>
               </a:ext>
             </a:extLst>
           </p:cNvPr>
@@ -4375,8 +4375,8 @@
           <p:nvPr/>
         </p:nvPicPr>
         <p:blipFill>
-          <a:blip xmlns:r="http://schemas.openxmlformats.org/officeDocument/2006/relationships" xmlns:a="http://schemas.openxmlformats.org/drawingml/2006/main" r:embed="R7b696e1ed46d4869"/>
-          <a:srcRect xmlns:a="http://schemas.openxmlformats.org/drawingml/2006/main" l="0" t="555" r="0" b="555"/>
+          <a:blip xmlns:r="http://schemas.openxmlformats.org/officeDocument/2006/relationships" xmlns:a="http://schemas.openxmlformats.org/drawingml/2006/main" r:embed="R84c4da81f21a4bbe"/>
+          <a:srcRect xmlns:a="http://schemas.openxmlformats.org/drawingml/2006/main" l="0" t="61" r="0" b="61"/>
           <a:stretch xmlns:a="http://schemas.openxmlformats.org/drawingml/2006/main">
             <a:fillRect l="0" t="0" r="0" b="0"/>
           </a:stretch>
@@ -4398,7 +4398,7 @@
           <p:cNvPr id="6" name="search-caption">
             <a:extLst xmlns:a="http://schemas.openxmlformats.org/drawingml/2006/main">
               <a:ext uri="{FF2B5EF4-FFF2-40B4-BE49-F238E27FC236}">
-                <a16:creationId xmlns:a16="http://schemas.microsoft.com/office/drawing/2014/main" id="{24EB4A5E-153F-4AA1-A580-E621C5929629}"/>
+                <a16:creationId xmlns:a16="http://schemas.microsoft.com/office/drawing/2014/main" id="{6894E4D8-CDD3-4D66-B808-9EF555AFBEF4}"/>
               </a:ext>
             </a:extLst>
           </p:cNvPr>
@@ -4456,7 +4456,7 @@
           <p:cNvPr id="7" name="library-image-frame">
             <a:extLst xmlns:a="http://schemas.openxmlformats.org/drawingml/2006/main">
               <a:ext uri="{FF2B5EF4-FFF2-40B4-BE49-F238E27FC236}">
-                <a16:creationId xmlns:a16="http://schemas.microsoft.com/office/drawing/2014/main" id="{75E505FA-124A-4515-9B12-7D51AD62C965}"/>
+                <a16:creationId xmlns:a16="http://schemas.microsoft.com/office/drawing/2014/main" id="{FE025FF5-1CA4-4BBD-823B-0748D1E16598}"/>
               </a:ext>
             </a:extLst>
           </p:cNvPr>
@@ -4495,8 +4495,8 @@
           <p:nvPr/>
         </p:nvPicPr>
         <p:blipFill>
-          <a:blip xmlns:r="http://schemas.openxmlformats.org/officeDocument/2006/relationships" xmlns:a="http://schemas.openxmlformats.org/drawingml/2006/main" r:embed="Rc498ca22d22e46e0"/>
-          <a:srcRect xmlns:a="http://schemas.openxmlformats.org/drawingml/2006/main" l="0" t="555" r="0" b="555"/>
+          <a:blip xmlns:r="http://schemas.openxmlformats.org/officeDocument/2006/relationships" xmlns:a="http://schemas.openxmlformats.org/drawingml/2006/main" r:embed="R8e7e22de9492489e"/>
+          <a:srcRect xmlns:a="http://schemas.openxmlformats.org/drawingml/2006/main" l="0" t="61" r="0" b="61"/>
           <a:stretch xmlns:a="http://schemas.openxmlformats.org/drawingml/2006/main">
             <a:fillRect l="0" t="0" r="0" b="0"/>
           </a:stretch>
@@ -4518,7 +4518,7 @@
           <p:cNvPr id="9" name="library-caption">
             <a:extLst xmlns:a="http://schemas.openxmlformats.org/drawingml/2006/main">
               <a:ext uri="{FF2B5EF4-FFF2-40B4-BE49-F238E27FC236}">
-                <a16:creationId xmlns:a16="http://schemas.microsoft.com/office/drawing/2014/main" id="{E066F779-8044-4FA5-A518-924B51F7657C}"/>
+                <a16:creationId xmlns:a16="http://schemas.microsoft.com/office/drawing/2014/main" id="{6D8717E0-086A-45C8-8196-43FA5F6CF8D0}"/>
               </a:ext>
             </a:extLst>
           </p:cNvPr>
@@ -4576,7 +4576,7 @@
           <p:cNvPr id="10" name="flow-strip">
             <a:extLst xmlns:a="http://schemas.openxmlformats.org/drawingml/2006/main">
               <a:ext uri="{FF2B5EF4-FFF2-40B4-BE49-F238E27FC236}">
-                <a16:creationId xmlns:a16="http://schemas.microsoft.com/office/drawing/2014/main" id="{2ED216F0-91AB-4059-9A87-461F9D1A1567}"/>
+                <a16:creationId xmlns:a16="http://schemas.microsoft.com/office/drawing/2014/main" id="{BE51D03F-CF26-40DA-95DB-1E8F095BC43C}"/>
               </a:ext>
             </a:extLst>
           </p:cNvPr>
@@ -4609,7 +4609,7 @@
           <p:cNvPr id="11" name="flow-search-label">
             <a:extLst xmlns:a="http://schemas.openxmlformats.org/drawingml/2006/main">
               <a:ext uri="{FF2B5EF4-FFF2-40B4-BE49-F238E27FC236}">
-                <a16:creationId xmlns:a16="http://schemas.microsoft.com/office/drawing/2014/main" id="{5093BFBC-55CC-490C-B750-A5CDC26F21D8}"/>
+                <a16:creationId xmlns:a16="http://schemas.microsoft.com/office/drawing/2014/main" id="{7548B10D-77F8-48AF-A351-78A79652C651}"/>
               </a:ext>
             </a:extLst>
           </p:cNvPr>
@@ -4667,7 +4667,7 @@
           <p:cNvPr id="12" name="flow-search-value">
             <a:extLst xmlns:a="http://schemas.openxmlformats.org/drawingml/2006/main">
               <a:ext uri="{FF2B5EF4-FFF2-40B4-BE49-F238E27FC236}">
-                <a16:creationId xmlns:a16="http://schemas.microsoft.com/office/drawing/2014/main" id="{F3284D22-F0BF-4291-A47F-7FE7B114D209}"/>
+                <a16:creationId xmlns:a16="http://schemas.microsoft.com/office/drawing/2014/main" id="{0591498B-3EE5-4541-A4A5-7623FDCC5E6C}"/>
               </a:ext>
             </a:extLst>
           </p:cNvPr>
@@ -4725,7 +4725,7 @@
           <p:cNvPr id="13" name="flow-library-label">
             <a:extLst xmlns:a="http://schemas.openxmlformats.org/drawingml/2006/main">
               <a:ext uri="{FF2B5EF4-FFF2-40B4-BE49-F238E27FC236}">
-                <a16:creationId xmlns:a16="http://schemas.microsoft.com/office/drawing/2014/main" id="{004C69C1-05F1-4723-8951-FB55E6F42582}"/>
+                <a16:creationId xmlns:a16="http://schemas.microsoft.com/office/drawing/2014/main" id="{5E862F59-9213-40A9-86E4-7E042D5082A7}"/>
               </a:ext>
             </a:extLst>
           </p:cNvPr>
@@ -4783,7 +4783,7 @@
           <p:cNvPr id="14" name="flow-library-value">
             <a:extLst xmlns:a="http://schemas.openxmlformats.org/drawingml/2006/main">
               <a:ext uri="{FF2B5EF4-FFF2-40B4-BE49-F238E27FC236}">
-                <a16:creationId xmlns:a16="http://schemas.microsoft.com/office/drawing/2014/main" id="{E3E8D64A-4B05-464E-B619-81787A57EC0F}"/>
+                <a16:creationId xmlns:a16="http://schemas.microsoft.com/office/drawing/2014/main" id="{2BCBE16A-3E57-47F4-BCD9-7760BB754BB6}"/>
               </a:ext>
             </a:extLst>
           </p:cNvPr>
@@ -4841,7 +4841,7 @@
           <p:cNvPr id="15" name="footer-rule">
             <a:extLst xmlns:a="http://schemas.openxmlformats.org/drawingml/2006/main">
               <a:ext uri="{FF2B5EF4-FFF2-40B4-BE49-F238E27FC236}">
-                <a16:creationId xmlns:a16="http://schemas.microsoft.com/office/drawing/2014/main" id="{9A81DCC9-DD42-4C53-9772-496FC3DF105B}"/>
+                <a16:creationId xmlns:a16="http://schemas.microsoft.com/office/drawing/2014/main" id="{BED45C69-247A-449A-94D5-33EE2B75ADF8}"/>
               </a:ext>
             </a:extLst>
           </p:cNvPr>
@@ -4872,7 +4872,7 @@
           <p:cNvPr id="16" name="footer">
             <a:extLst xmlns:a="http://schemas.openxmlformats.org/drawingml/2006/main">
               <a:ext uri="{FF2B5EF4-FFF2-40B4-BE49-F238E27FC236}">
-                <a16:creationId xmlns:a16="http://schemas.microsoft.com/office/drawing/2014/main" id="{046267E1-84F6-43FF-BC94-752F7FB5C2D9}"/>
+                <a16:creationId xmlns:a16="http://schemas.microsoft.com/office/drawing/2014/main" id="{0A954DE7-5E76-4A7D-A8CB-C9AC4817876F}"/>
               </a:ext>
             </a:extLst>
           </p:cNvPr>
@@ -4928,7 +4928,7 @@
     </p:spTree>
     <p:extLst>
       <p:ext uri="{BB962C8B-B14F-4D97-AF65-F5344CB8AC3E}">
-        <p14:creationId xmlns:p14="http://schemas.microsoft.com/office/powerpoint/2010/main" val="46696758"/>
+        <p14:creationId xmlns:p14="http://schemas.microsoft.com/office/powerpoint/2010/main" val="1000189780"/>
       </p:ext>
     </p:extLst>
   </p:cSld>
@@ -4959,7 +4959,7 @@
           <p:cNvPr id="17" name="eyebrow-5">
             <a:extLst xmlns:a="http://schemas.openxmlformats.org/drawingml/2006/main">
               <a:ext uri="{FF2B5EF4-FFF2-40B4-BE49-F238E27FC236}">
-                <a16:creationId xmlns:a16="http://schemas.microsoft.com/office/drawing/2014/main" id="{3241C458-5337-4571-816B-363B02CC703F}"/>
+                <a16:creationId xmlns:a16="http://schemas.microsoft.com/office/drawing/2014/main" id="{7D593C34-5AB8-4799-9972-15E52B6D2AF3}"/>
               </a:ext>
             </a:extLst>
           </p:cNvPr>
@@ -5017,7 +5017,7 @@
           <p:cNvPr id="2" name="title-5">
             <a:extLst xmlns:a="http://schemas.openxmlformats.org/drawingml/2006/main">
               <a:ext uri="{FF2B5EF4-FFF2-40B4-BE49-F238E27FC236}">
-                <a16:creationId xmlns:a16="http://schemas.microsoft.com/office/drawing/2014/main" id="{E61E9532-68A9-4033-911F-8795A4C78F14}"/>
+                <a16:creationId xmlns:a16="http://schemas.microsoft.com/office/drawing/2014/main" id="{10B00FE4-9A04-4612-BB00-065B3F2D9F2A}"/>
               </a:ext>
             </a:extLst>
           </p:cNvPr>
@@ -5065,7 +5065,7 @@
                 <a:ea typeface="Helvetica Neue"/>
                 <a:cs typeface="Helvetica Neue"/>
               </a:rPr>
-              <a:t>Settings and connected services</a:t>
+              <a:t>Appearance and color themes</a:t>
             </a:r>
           </a:p>
         </p:txBody>
@@ -5075,7 +5075,7 @@
           <p:cNvPr id="3" name="page-5">
             <a:extLst xmlns:a="http://schemas.openxmlformats.org/drawingml/2006/main">
               <a:ext uri="{FF2B5EF4-FFF2-40B4-BE49-F238E27FC236}">
-                <a16:creationId xmlns:a16="http://schemas.microsoft.com/office/drawing/2014/main" id="{ED08DA10-1C37-42CE-BA67-B299BB6C5CA1}"/>
+                <a16:creationId xmlns:a16="http://schemas.microsoft.com/office/drawing/2014/main" id="{570C8A82-19B7-409D-A809-7075308430F7}"/>
               </a:ext>
             </a:extLst>
           </p:cNvPr>
@@ -5130,10 +5130,10 @@
       </p:sp>
       <p:sp>
         <p:nvSpPr>
-          <p:cNvPr id="4" name="settings-image-frame">
-            <a:extLst xmlns:a="http://schemas.openxmlformats.org/drawingml/2006/main">
-              <a:ext uri="{FF2B5EF4-FFF2-40B4-BE49-F238E27FC236}">
-                <a16:creationId xmlns:a16="http://schemas.microsoft.com/office/drawing/2014/main" id="{B7B46414-15CA-453F-9AB1-2281934194EB}"/>
+          <p:cNvPr id="4" name="appearance-image-frame">
+            <a:extLst xmlns:a="http://schemas.openxmlformats.org/drawingml/2006/main">
+              <a:ext uri="{FF2B5EF4-FFF2-40B4-BE49-F238E27FC236}">
+                <a16:creationId xmlns:a16="http://schemas.microsoft.com/office/drawing/2014/main" id="{23925A17-5FFC-409B-9513-25612660E34A}"/>
               </a:ext>
             </a:extLst>
           </p:cNvPr>
@@ -5172,8 +5172,8 @@
           <p:nvPr/>
         </p:nvPicPr>
         <p:blipFill>
-          <a:blip xmlns:r="http://schemas.openxmlformats.org/officeDocument/2006/relationships" xmlns:a="http://schemas.openxmlformats.org/drawingml/2006/main" r:embed="Rbc077a382bc34858"/>
-          <a:srcRect xmlns:a="http://schemas.openxmlformats.org/drawingml/2006/main" l="0" t="550" r="0" b="550"/>
+          <a:blip xmlns:r="http://schemas.openxmlformats.org/officeDocument/2006/relationships" xmlns:a="http://schemas.openxmlformats.org/drawingml/2006/main" r:embed="R7a2264d92dd34e7a"/>
+          <a:srcRect xmlns:a="http://schemas.openxmlformats.org/drawingml/2006/main" l="0" t="56" r="0" b="56"/>
           <a:stretch xmlns:a="http://schemas.openxmlformats.org/drawingml/2006/main">
             <a:fillRect l="0" t="0" r="0" b="0"/>
           </a:stretch>
@@ -5192,10 +5192,10 @@
       </p:pic>
       <p:sp>
         <p:nvSpPr>
-          <p:cNvPr id="6" name="settings-caption">
-            <a:extLst xmlns:a="http://schemas.openxmlformats.org/drawingml/2006/main">
-              <a:ext uri="{FF2B5EF4-FFF2-40B4-BE49-F238E27FC236}">
-                <a16:creationId xmlns:a16="http://schemas.microsoft.com/office/drawing/2014/main" id="{FDDE9A7C-B111-4461-AEB3-686D91E580B6}"/>
+          <p:cNvPr id="6" name="appearance-caption">
+            <a:extLst xmlns:a="http://schemas.openxmlformats.org/drawingml/2006/main">
+              <a:ext uri="{FF2B5EF4-FFF2-40B4-BE49-F238E27FC236}">
+                <a16:creationId xmlns:a16="http://schemas.microsoft.com/office/drawing/2014/main" id="{63731F5D-C8AD-4631-AD1C-0D33F0EAD867}"/>
               </a:ext>
             </a:extLst>
           </p:cNvPr>
@@ -5243,7 +5243,7 @@
                 <a:ea typeface="Helvetica Neue"/>
                 <a:cs typeface="Helvetica Neue"/>
               </a:rPr>
-              <a:t>Settings screen captured from the local TV build</a:t>
+              <a:t>Appearance screen captured from the local English TV build</a:t>
             </a:r>
           </a:p>
         </p:txBody>
@@ -5253,7 +5253,7 @@
           <p:cNvPr id="7" name="label-194">
             <a:extLst xmlns:a="http://schemas.openxmlformats.org/drawingml/2006/main">
               <a:ext uri="{FF2B5EF4-FFF2-40B4-BE49-F238E27FC236}">
-                <a16:creationId xmlns:a16="http://schemas.microsoft.com/office/drawing/2014/main" id="{229812CF-0CA4-4F73-AC1B-3B1A53234B8E}"/>
+                <a16:creationId xmlns:a16="http://schemas.microsoft.com/office/drawing/2014/main" id="{C6D9ED7E-F3F3-4512-95B7-BCAA29A84307}"/>
               </a:ext>
             </a:extLst>
           </p:cNvPr>
@@ -5301,7 +5301,7 @@
                 <a:ea typeface="Helvetica Neue"/>
                 <a:cs typeface="Helvetica Neue"/>
               </a:rPr>
-              <a:t>ACCOUNT</a:t>
+              <a:t>COLOR THEME</a:t>
             </a:r>
           </a:p>
         </p:txBody>
@@ -5311,7 +5311,7 @@
           <p:cNvPr id="8" name="value-194">
             <a:extLst xmlns:a="http://schemas.openxmlformats.org/drawingml/2006/main">
               <a:ext uri="{FF2B5EF4-FFF2-40B4-BE49-F238E27FC236}">
-                <a16:creationId xmlns:a16="http://schemas.microsoft.com/office/drawing/2014/main" id="{CD3DC34C-98B7-4B52-9774-78D491732D10}"/>
+                <a16:creationId xmlns:a16="http://schemas.microsoft.com/office/drawing/2014/main" id="{C8969853-FBB0-467E-914F-69E401285919}"/>
               </a:ext>
             </a:extLst>
           </p:cNvPr>
@@ -5359,7 +5359,7 @@
                 <a:ea typeface="Helvetica Neue"/>
                 <a:cs typeface="Helvetica Neue"/>
               </a:rPr>
-              <a:t>Profile state and supported watch-history synchronization.</a:t>
+              <a:t>Choose the accent color used throughout the TV experience.</a:t>
             </a:r>
           </a:p>
         </p:txBody>
@@ -5369,7 +5369,7 @@
           <p:cNvPr id="9" name="label-300">
             <a:extLst xmlns:a="http://schemas.openxmlformats.org/drawingml/2006/main">
               <a:ext uri="{FF2B5EF4-FFF2-40B4-BE49-F238E27FC236}">
-                <a16:creationId xmlns:a16="http://schemas.microsoft.com/office/drawing/2014/main" id="{38873E60-4C58-4BE5-AD5E-004F69CA52C8}"/>
+                <a16:creationId xmlns:a16="http://schemas.microsoft.com/office/drawing/2014/main" id="{CDEA4BD8-A557-4FDB-B22D-0F345DFAEF8A}"/>
               </a:ext>
             </a:extLst>
           </p:cNvPr>
@@ -5417,7 +5417,7 @@
                 <a:ea typeface="Helvetica Neue"/>
                 <a:cs typeface="Helvetica Neue"/>
               </a:rPr>
-              <a:t>INTEGRATIONS</a:t>
+              <a:t>AMOLED MODE</a:t>
             </a:r>
           </a:p>
         </p:txBody>
@@ -5427,7 +5427,7 @@
           <p:cNvPr id="10" name="value-300">
             <a:extLst xmlns:a="http://schemas.openxmlformats.org/drawingml/2006/main">
               <a:ext uri="{FF2B5EF4-FFF2-40B4-BE49-F238E27FC236}">
-                <a16:creationId xmlns:a16="http://schemas.microsoft.com/office/drawing/2014/main" id="{1FDFC979-3952-48DD-ADF3-98D0DD6570DD}"/>
+                <a16:creationId xmlns:a16="http://schemas.microsoft.com/office/drawing/2014/main" id="{19115DC1-8CEF-4AE6-88B3-B771DF68E258}"/>
               </a:ext>
             </a:extLst>
           </p:cNvPr>
@@ -5475,7 +5475,7 @@
                 <a:ea typeface="Helvetica Neue"/>
                 <a:cs typeface="Helvetica Neue"/>
               </a:rPr>
-              <a:t>Optional services for cloud libraries and playable links.</a:t>
+              <a:t>Use pure black backgrounds for a high-contrast dark presentation.</a:t>
             </a:r>
           </a:p>
         </p:txBody>
@@ -5485,7 +5485,7 @@
           <p:cNvPr id="11" name="label-406">
             <a:extLst xmlns:a="http://schemas.openxmlformats.org/drawingml/2006/main">
               <a:ext uri="{FF2B5EF4-FFF2-40B4-BE49-F238E27FC236}">
-                <a16:creationId xmlns:a16="http://schemas.microsoft.com/office/drawing/2014/main" id="{D5A13237-2F24-4C80-8AFC-4827FD03A96B}"/>
+                <a16:creationId xmlns:a16="http://schemas.microsoft.com/office/drawing/2014/main" id="{E3709BDF-80A6-425F-841C-41FF3DFCE0F3}"/>
               </a:ext>
             </a:extLst>
           </p:cNvPr>
@@ -5533,7 +5533,7 @@
                 <a:ea typeface="Helvetica Neue"/>
                 <a:cs typeface="Helvetica Neue"/>
               </a:rPr>
-              <a:t>PLAYBACK</a:t>
+              <a:t>SETTINGS STYLE</a:t>
             </a:r>
           </a:p>
         </p:txBody>
@@ -5543,7 +5543,7 @@
           <p:cNvPr id="12" name="value-406">
             <a:extLst xmlns:a="http://schemas.openxmlformats.org/drawingml/2006/main">
               <a:ext uri="{FF2B5EF4-FFF2-40B4-BE49-F238E27FC236}">
-                <a16:creationId xmlns:a16="http://schemas.microsoft.com/office/drawing/2014/main" id="{848969C5-7A8E-47D9-92BC-41B8047A0C8D}"/>
+                <a16:creationId xmlns:a16="http://schemas.microsoft.com/office/drawing/2014/main" id="{3D2B94E8-9237-4B52-AE25-B2CE71F96E8A}"/>
               </a:ext>
             </a:extLst>
           </p:cNvPr>
@@ -5591,7 +5591,7 @@
                 <a:ea typeface="Helvetica Neue"/>
                 <a:cs typeface="Helvetica Neue"/>
               </a:rPr>
-              <a:t>Player, audio, subtitle and accessibility preferences.</a:t>
+              <a:t>Choose how settings screens are presented on the TV.</a:t>
             </a:r>
           </a:p>
         </p:txBody>
@@ -5601,7 +5601,7 @@
           <p:cNvPr id="13" name="label-512">
             <a:extLst xmlns:a="http://schemas.openxmlformats.org/drawingml/2006/main">
               <a:ext uri="{FF2B5EF4-FFF2-40B4-BE49-F238E27FC236}">
-                <a16:creationId xmlns:a16="http://schemas.microsoft.com/office/drawing/2014/main" id="{EB38FB08-B59E-429C-A617-FCD665F3DE71}"/>
+                <a16:creationId xmlns:a16="http://schemas.microsoft.com/office/drawing/2014/main" id="{221F522D-CACC-4486-8A6A-3AFAEC40BA1F}"/>
               </a:ext>
             </a:extLst>
           </p:cNvPr>
@@ -5649,7 +5649,7 @@
                 <a:ea typeface="Helvetica Neue"/>
                 <a:cs typeface="Helvetica Neue"/>
               </a:rPr>
-              <a:t>ADVANCED</a:t>
+              <a:t>LANGUAGE</a:t>
             </a:r>
           </a:p>
         </p:txBody>
@@ -5659,7 +5659,7 @@
           <p:cNvPr id="14" name="value-512">
             <a:extLst xmlns:a="http://schemas.openxmlformats.org/drawingml/2006/main">
               <a:ext uri="{FF2B5EF4-FFF2-40B4-BE49-F238E27FC236}">
-                <a16:creationId xmlns:a16="http://schemas.microsoft.com/office/drawing/2014/main" id="{BED54BCD-C5AF-4EEE-B56D-62049775B7B8}"/>
+                <a16:creationId xmlns:a16="http://schemas.microsoft.com/office/drawing/2014/main" id="{CFEB0CE2-9EB0-4875-927B-F0DA944F49F5}"/>
               </a:ext>
             </a:extLst>
           </p:cNvPr>
@@ -5707,7 +5707,7 @@
                 <a:ea typeface="Helvetica Neue"/>
                 <a:cs typeface="Helvetica Neue"/>
               </a:rPr>
-              <a:t>Capabilities are exposed according to the TV platform and package profile.</a:t>
+              <a:t>Override the system language with one of the supported app locales.</a:t>
             </a:r>
           </a:p>
         </p:txBody>
@@ -5717,7 +5717,7 @@
           <p:cNvPr id="15" name="footer-rule">
             <a:extLst xmlns:a="http://schemas.openxmlformats.org/drawingml/2006/main">
               <a:ext uri="{FF2B5EF4-FFF2-40B4-BE49-F238E27FC236}">
-                <a16:creationId xmlns:a16="http://schemas.microsoft.com/office/drawing/2014/main" id="{DB09823A-6972-4C2D-9722-3099BC020487}"/>
+                <a16:creationId xmlns:a16="http://schemas.microsoft.com/office/drawing/2014/main" id="{846D2617-79A1-4174-988E-994132640528}"/>
               </a:ext>
             </a:extLst>
           </p:cNvPr>
@@ -5748,7 +5748,7 @@
           <p:cNvPr id="16" name="footer">
             <a:extLst xmlns:a="http://schemas.openxmlformats.org/drawingml/2006/main">
               <a:ext uri="{FF2B5EF4-FFF2-40B4-BE49-F238E27FC236}">
-                <a16:creationId xmlns:a16="http://schemas.microsoft.com/office/drawing/2014/main" id="{1B1A5875-47E7-4F50-960F-A1754B9CDCFB}"/>
+                <a16:creationId xmlns:a16="http://schemas.microsoft.com/office/drawing/2014/main" id="{3EB09C13-0D09-485C-B43E-5F0CD36D5EFD}"/>
               </a:ext>
             </a:extLst>
           </p:cNvPr>
@@ -5804,7 +5804,7 @@
     </p:spTree>
     <p:extLst>
       <p:ext uri="{BB962C8B-B14F-4D97-AF65-F5344CB8AC3E}">
-        <p14:creationId xmlns:p14="http://schemas.microsoft.com/office/powerpoint/2010/main" val="1399156274"/>
+        <p14:creationId xmlns:p14="http://schemas.microsoft.com/office/powerpoint/2010/main" val="1321171288"/>
       </p:ext>
     </p:extLst>
   </p:cSld>
@@ -5835,7 +5835,7 @@
           <p:cNvPr id="22" name="eyebrow-6">
             <a:extLst xmlns:a="http://schemas.openxmlformats.org/drawingml/2006/main">
               <a:ext uri="{FF2B5EF4-FFF2-40B4-BE49-F238E27FC236}">
-                <a16:creationId xmlns:a16="http://schemas.microsoft.com/office/drawing/2014/main" id="{999B4576-BA45-49B3-A8FF-11CDBEC74502}"/>
+                <a16:creationId xmlns:a16="http://schemas.microsoft.com/office/drawing/2014/main" id="{A948835C-8EA1-4F8D-BE66-7020CCE65C99}"/>
               </a:ext>
             </a:extLst>
           </p:cNvPr>
@@ -5883,7 +5883,7 @@
                 <a:ea typeface="Helvetica Neue"/>
                 <a:cs typeface="Helvetica Neue"/>
               </a:rPr>
-              <a:t>CERTIFICATION DISCLOSURE</a:t>
+              <a:t>CERTIFICATION PROFILE</a:t>
             </a:r>
           </a:p>
         </p:txBody>
@@ -5893,7 +5893,7 @@
           <p:cNvPr id="2" name="title-6">
             <a:extLst xmlns:a="http://schemas.openxmlformats.org/drawingml/2006/main">
               <a:ext uri="{FF2B5EF4-FFF2-40B4-BE49-F238E27FC236}">
-                <a16:creationId xmlns:a16="http://schemas.microsoft.com/office/drawing/2014/main" id="{86DD5831-C84F-48C3-9339-5B19AB9DA70A}"/>
+                <a16:creationId xmlns:a16="http://schemas.microsoft.com/office/drawing/2014/main" id="{DEA5616E-0396-4AF0-84FD-E98FB345EDA9}"/>
               </a:ext>
             </a:extLst>
           </p:cNvPr>
@@ -5941,7 +5941,7 @@
                 <a:ea typeface="Helvetica Neue"/>
                 <a:cs typeface="Helvetica Neue"/>
               </a:rPr>
-              <a:t>Capabilities follow the package profile</a:t>
+              <a:t>Sources and platform routes</a:t>
             </a:r>
           </a:p>
         </p:txBody>
@@ -5951,7 +5951,7 @@
           <p:cNvPr id="3" name="page-6">
             <a:extLst xmlns:a="http://schemas.openxmlformats.org/drawingml/2006/main">
               <a:ext uri="{FF2B5EF4-FFF2-40B4-BE49-F238E27FC236}">
-                <a16:creationId xmlns:a16="http://schemas.microsoft.com/office/drawing/2014/main" id="{19A24738-82E6-4430-B7E7-20B40865B945}"/>
+                <a16:creationId xmlns:a16="http://schemas.microsoft.com/office/drawing/2014/main" id="{CA721E00-90F2-487C-8D48-EC3DB5EF3710}"/>
               </a:ext>
             </a:extLst>
           </p:cNvPr>
@@ -6009,7 +6009,7 @@
           <p:cNvPr id="4" name="disclosure-intro">
             <a:extLst xmlns:a="http://schemas.openxmlformats.org/drawingml/2006/main">
               <a:ext uri="{FF2B5EF4-FFF2-40B4-BE49-F238E27FC236}">
-                <a16:creationId xmlns:a16="http://schemas.microsoft.com/office/drawing/2014/main" id="{5447CA56-4A0A-4EE6-AD17-7FD1DF64A81B}"/>
+                <a16:creationId xmlns:a16="http://schemas.microsoft.com/office/drawing/2014/main" id="{0DDAF23A-DDBF-44B6-B9E3-39E1A95C4E5D}"/>
               </a:ext>
             </a:extLst>
           </p:cNvPr>
@@ -6021,7 +6021,7 @@
         <p:spPr>
           <a:xfrm xmlns:a="http://schemas.openxmlformats.org/drawingml/2006/main">
             <a:off x="495300" y="1466850"/>
-            <a:ext cx="9239250" cy="342900"/>
+            <a:ext cx="10668000" cy="342900"/>
           </a:xfrm>
           <a:prstGeom xmlns:a="http://schemas.openxmlformats.org/drawingml/2006/main" prst="rect">
             <a:avLst/>
@@ -6057,7 +6057,7 @@
                 <a:ea typeface="Helvetica Neue"/>
                 <a:cs typeface="Helvetica Neue"/>
               </a:rPr>
-              <a:t>The UI remains consistent; platform capabilities are declared honestly at runtime.</a:t>
+              <a:t>Nuvio keeps the TV experience consistent while the signed package follows the selected store profile.</a:t>
             </a:r>
           </a:p>
         </p:txBody>
@@ -6067,7 +6067,7 @@
           <p:cNvPr id="5" name="disclosure-card-0">
             <a:extLst xmlns:a="http://schemas.openxmlformats.org/drawingml/2006/main">
               <a:ext uri="{FF2B5EF4-FFF2-40B4-BE49-F238E27FC236}">
-                <a16:creationId xmlns:a16="http://schemas.microsoft.com/office/drawing/2014/main" id="{BF0644AA-A6FC-4815-8387-A2A59E64F8D3}"/>
+                <a16:creationId xmlns:a16="http://schemas.microsoft.com/office/drawing/2014/main" id="{39634449-567E-48EE-9CDD-AF0269B865EC}"/>
               </a:ext>
             </a:extLst>
           </p:cNvPr>
@@ -6102,7 +6102,7 @@
           <p:cNvPr id="6" name="disclosure-head-0">
             <a:extLst xmlns:a="http://schemas.openxmlformats.org/drawingml/2006/main">
               <a:ext uri="{FF2B5EF4-FFF2-40B4-BE49-F238E27FC236}">
-                <a16:creationId xmlns:a16="http://schemas.microsoft.com/office/drawing/2014/main" id="{DAFA8257-3052-4511-AE85-B21D402E05ED}"/>
+                <a16:creationId xmlns:a16="http://schemas.microsoft.com/office/drawing/2014/main" id="{D02DB8CA-B3B2-4809-9293-665E7E1A1F8E}"/>
               </a:ext>
             </a:extLst>
           </p:cNvPr>
@@ -6160,7 +6160,7 @@
           <p:cNvPr id="7" name="disclosure-value-0">
             <a:extLst xmlns:a="http://schemas.openxmlformats.org/drawingml/2006/main">
               <a:ext uri="{FF2B5EF4-FFF2-40B4-BE49-F238E27FC236}">
-                <a16:creationId xmlns:a16="http://schemas.microsoft.com/office/drawing/2014/main" id="{93EC70DC-DEBC-4300-939C-C0F140EBB771}"/>
+                <a16:creationId xmlns:a16="http://schemas.microsoft.com/office/drawing/2014/main" id="{34381D32-493F-4D24-A7A5-7D5CF2819CF3}"/>
               </a:ext>
             </a:extLst>
           </p:cNvPr>
@@ -6241,7 +6241,7 @@
           <p:cNvPr id="8" name="disclosure-card-1">
             <a:extLst xmlns:a="http://schemas.openxmlformats.org/drawingml/2006/main">
               <a:ext uri="{FF2B5EF4-FFF2-40B4-BE49-F238E27FC236}">
-                <a16:creationId xmlns:a16="http://schemas.microsoft.com/office/drawing/2014/main" id="{2BFCA1BF-6F38-446A-8D09-BF6A24425EEA}"/>
+                <a16:creationId xmlns:a16="http://schemas.microsoft.com/office/drawing/2014/main" id="{7AB1AF70-8B05-48A8-9A4A-FF2A31F0E0B2}"/>
               </a:ext>
             </a:extLst>
           </p:cNvPr>
@@ -6276,7 +6276,7 @@
           <p:cNvPr id="9" name="disclosure-head-1">
             <a:extLst xmlns:a="http://schemas.openxmlformats.org/drawingml/2006/main">
               <a:ext uri="{FF2B5EF4-FFF2-40B4-BE49-F238E27FC236}">
-                <a16:creationId xmlns:a16="http://schemas.microsoft.com/office/drawing/2014/main" id="{3A918090-5F93-4A04-8659-845D961CD4F4}"/>
+                <a16:creationId xmlns:a16="http://schemas.microsoft.com/office/drawing/2014/main" id="{E6A25773-A975-4939-9858-1F5381F0D09F}"/>
               </a:ext>
             </a:extLst>
           </p:cNvPr>
@@ -6324,7 +6324,7 @@
                 <a:ea typeface="Helvetica Neue"/>
                 <a:cs typeface="Helvetica Neue"/>
               </a:rPr>
-              <a:t>PUBLIC SELLER</a:t>
+              <a:t>DISTRIBUTION</a:t>
             </a:r>
           </a:p>
         </p:txBody>
@@ -6334,7 +6334,7 @@
           <p:cNvPr id="10" name="disclosure-value-1">
             <a:extLst xmlns:a="http://schemas.openxmlformats.org/drawingml/2006/main">
               <a:ext uri="{FF2B5EF4-FFF2-40B4-BE49-F238E27FC236}">
-                <a16:creationId xmlns:a16="http://schemas.microsoft.com/office/drawing/2014/main" id="{F8CE3C61-0BB5-4039-BF91-FDD3F7A66EB1}"/>
+                <a16:creationId xmlns:a16="http://schemas.microsoft.com/office/drawing/2014/main" id="{7D49FCEA-0471-4C37-8769-A302C0454D02}"/>
               </a:ext>
             </a:extLst>
           </p:cNvPr>
@@ -6382,7 +6382,7 @@
                 <a:ea typeface="Helvetica Neue"/>
                 <a:cs typeface="Helvetica Neue"/>
               </a:rPr>
-              <a:t>US distribution by default; public privileges only.</a:t>
+              <a:t>Public Seller flow with the countries and model groups approved in Seller Office.</a:t>
             </a:r>
           </a:p>
         </p:txBody>
@@ -6392,7 +6392,7 @@
           <p:cNvPr id="11" name="disclosure-card-2">
             <a:extLst xmlns:a="http://schemas.openxmlformats.org/drawingml/2006/main">
               <a:ext uri="{FF2B5EF4-FFF2-40B4-BE49-F238E27FC236}">
-                <a16:creationId xmlns:a16="http://schemas.microsoft.com/office/drawing/2014/main" id="{FFB7DD2E-19FE-4445-B20A-9E8776522F0C}"/>
+                <a16:creationId xmlns:a16="http://schemas.microsoft.com/office/drawing/2014/main" id="{468FE248-CFC1-4141-A652-416A5671A5E5}"/>
               </a:ext>
             </a:extLst>
           </p:cNvPr>
@@ -6427,7 +6427,7 @@
           <p:cNvPr id="12" name="disclosure-head-2">
             <a:extLst xmlns:a="http://schemas.openxmlformats.org/drawingml/2006/main">
               <a:ext uri="{FF2B5EF4-FFF2-40B4-BE49-F238E27FC236}">
-                <a16:creationId xmlns:a16="http://schemas.microsoft.com/office/drawing/2014/main" id="{72193FD7-9938-4017-865A-1B5CAF3F5518}"/>
+                <a16:creationId xmlns:a16="http://schemas.microsoft.com/office/drawing/2014/main" id="{49D6078A-2001-47CF-80B9-B14F61916896}"/>
               </a:ext>
             </a:extLst>
           </p:cNvPr>
@@ -6475,7 +6475,7 @@
                 <a:ea typeface="Helvetica Neue"/>
                 <a:cs typeface="Helvetica Neue"/>
               </a:rPr>
-              <a:t>PARTNER ROUTE</a:t>
+              <a:t>SOURCE MODEL</a:t>
             </a:r>
           </a:p>
         </p:txBody>
@@ -6485,7 +6485,7 @@
           <p:cNvPr id="13" name="disclosure-value-2">
             <a:extLst xmlns:a="http://schemas.openxmlformats.org/drawingml/2006/main">
               <a:ext uri="{FF2B5EF4-FFF2-40B4-BE49-F238E27FC236}">
-                <a16:creationId xmlns:a16="http://schemas.microsoft.com/office/drawing/2014/main" id="{A310E7CA-0D4B-40F5-A3DA-B472404F5D23}"/>
+                <a16:creationId xmlns:a16="http://schemas.microsoft.com/office/drawing/2014/main" id="{D0C6173F-6231-4E31-905E-C0D40F71BF9D}"/>
               </a:ext>
             </a:extLst>
           </p:cNvPr>
@@ -6533,7 +6533,7 @@
                 <a:ea typeface="Helvetica Neue"/>
                 <a:cs typeface="Helvetica Neue"/>
               </a:rPr>
-              <a:t>Required for countries outside the US and partner-level APIs.</a:t>
+              <a:t>User-configured catalogs, add-ons and supported services provide the playable sources.</a:t>
             </a:r>
           </a:p>
         </p:txBody>
@@ -6543,7 +6543,7 @@
           <p:cNvPr id="14" name="disclosure-card-3">
             <a:extLst xmlns:a="http://schemas.openxmlformats.org/drawingml/2006/main">
               <a:ext uri="{FF2B5EF4-FFF2-40B4-BE49-F238E27FC236}">
-                <a16:creationId xmlns:a16="http://schemas.microsoft.com/office/drawing/2014/main" id="{86BEC21E-CEEE-4B11-9C7F-7C861FD2E38C}"/>
+                <a16:creationId xmlns:a16="http://schemas.microsoft.com/office/drawing/2014/main" id="{3245581D-D347-4507-86E3-BC05FA70FE60}"/>
               </a:ext>
             </a:extLst>
           </p:cNvPr>
@@ -6563,11 +6563,11 @@
             </a:avLst>
           </a:prstGeom>
           <a:solidFill xmlns:a="http://schemas.openxmlformats.org/drawingml/2006/main">
-            <a:srgbClr val="2A2020"/>
+            <a:srgbClr val="1A1C24"/>
           </a:solidFill>
           <a:ln xmlns:a="http://schemas.openxmlformats.org/drawingml/2006/main" w="9525">
             <a:solidFill>
-              <a:srgbClr val="8D4B4B"/>
+              <a:srgbClr val="3B4050"/>
             </a:solidFill>
             <a:prstDash val="solid"/>
           </a:ln>
@@ -6578,7 +6578,7 @@
           <p:cNvPr id="15" name="disclosure-head-3">
             <a:extLst xmlns:a="http://schemas.openxmlformats.org/drawingml/2006/main">
               <a:ext uri="{FF2B5EF4-FFF2-40B4-BE49-F238E27FC236}">
-                <a16:creationId xmlns:a16="http://schemas.microsoft.com/office/drawing/2014/main" id="{3DDAED19-388D-486C-8088-C6D5CB6C3645}"/>
+                <a16:creationId xmlns:a16="http://schemas.microsoft.com/office/drawing/2014/main" id="{85B7965C-2E45-4E5E-9F55-640E94118F3D}"/>
               </a:ext>
             </a:extLst>
           </p:cNvPr>
@@ -6610,7 +6610,7 @@
             <a:pPr algn="l">
               <a:defRPr sz="900" b="1">
                 <a:solidFill>
-                  <a:srgbClr val="FFAA9A"/>
+                  <a:srgbClr val="F4B83F"/>
                 </a:solidFill>
                 <a:latin typeface="Helvetica Neue"/>
                 <a:ea typeface="Helvetica Neue"/>
@@ -6620,13 +6620,13 @@
             <a:r>
               <a:rPr sz="900" b="1">
                 <a:solidFill>
-                  <a:srgbClr val="FFAA9A"/>
-                </a:solidFill>
-                <a:latin typeface="Helvetica Neue"/>
-                <a:ea typeface="Helvetica Neue"/>
-                <a:cs typeface="Helvetica Neue"/>
-              </a:rPr>
-              <a:t>CURRENT RULE</a:t>
+                  <a:srgbClr val="F4B83F"/>
+                </a:solidFill>
+                <a:latin typeface="Helvetica Neue"/>
+                <a:ea typeface="Helvetica Neue"/>
+                <a:cs typeface="Helvetica Neue"/>
+              </a:rPr>
+              <a:t>RELEASE CONTROL</a:t>
             </a:r>
           </a:p>
         </p:txBody>
@@ -6636,7 +6636,7 @@
           <p:cNvPr id="16" name="disclosure-value-3">
             <a:extLst xmlns:a="http://schemas.openxmlformats.org/drawingml/2006/main">
               <a:ext uri="{FF2B5EF4-FFF2-40B4-BE49-F238E27FC236}">
-                <a16:creationId xmlns:a16="http://schemas.microsoft.com/office/drawing/2014/main" id="{A0FA90D5-577D-4333-A4CF-BC4DED468874}"/>
+                <a16:creationId xmlns:a16="http://schemas.microsoft.com/office/drawing/2014/main" id="{751AA2EF-631C-4FA4-9A03-0FF9A6D9E648}"/>
               </a:ext>
             </a:extLst>
           </p:cNvPr>
@@ -6684,7 +6684,7 @@
                 <a:ea typeface="Helvetica Neue"/>
                 <a:cs typeface="Helvetica Neue"/>
               </a:rPr>
-              <a:t>Torrent/P2P is enabled only when the signed package and Samsung approval authorize the service route.</a:t>
+              <a:t>The signed WGT must contain exactly the privileges, metadata and service routes approved for the release.</a:t>
             </a:r>
           </a:p>
         </p:txBody>
@@ -6694,7 +6694,7 @@
           <p:cNvPr id="17" name="disclosure-note">
             <a:extLst xmlns:a="http://schemas.openxmlformats.org/drawingml/2006/main">
               <a:ext uri="{FF2B5EF4-FFF2-40B4-BE49-F238E27FC236}">
-                <a16:creationId xmlns:a16="http://schemas.microsoft.com/office/drawing/2014/main" id="{E2C029C1-FE4A-4191-9485-7BDCF7EB0807}"/>
+                <a16:creationId xmlns:a16="http://schemas.microsoft.com/office/drawing/2014/main" id="{5B69C376-741F-416D-BCFA-A88B8D4D7101}"/>
               </a:ext>
             </a:extLst>
           </p:cNvPr>
@@ -6727,7 +6727,7 @@
           <p:cNvPr id="18" name="submission-note-label">
             <a:extLst xmlns:a="http://schemas.openxmlformats.org/drawingml/2006/main">
               <a:ext uri="{FF2B5EF4-FFF2-40B4-BE49-F238E27FC236}">
-                <a16:creationId xmlns:a16="http://schemas.microsoft.com/office/drawing/2014/main" id="{374F8B56-368E-4774-A5C3-8112C02DD501}"/>
+                <a16:creationId xmlns:a16="http://schemas.microsoft.com/office/drawing/2014/main" id="{5C874C27-1940-46FA-A255-04C52B20A50F}"/>
               </a:ext>
             </a:extLst>
           </p:cNvPr>
@@ -6785,7 +6785,7 @@
           <p:cNvPr id="19" name="submission-note-value">
             <a:extLst xmlns:a="http://schemas.openxmlformats.org/drawingml/2006/main">
               <a:ext uri="{FF2B5EF4-FFF2-40B4-BE49-F238E27FC236}">
-                <a16:creationId xmlns:a16="http://schemas.microsoft.com/office/drawing/2014/main" id="{2571F465-D200-42AE-830C-BF67EE592E99}"/>
+                <a16:creationId xmlns:a16="http://schemas.microsoft.com/office/drawing/2014/main" id="{F4086E06-5845-44E7-ADD9-0641178B6E80}"/>
               </a:ext>
             </a:extLst>
           </p:cNvPr>
@@ -6833,7 +6833,7 @@
                 <a:ea typeface="Helvetica Neue"/>
                 <a:cs typeface="Helvetica Neue"/>
               </a:rPr>
-              <a:t>The final WGT must be signed with the publisher’s Tizen security profile and must contain exactly the privileges and metadata approved in Seller Office. This UI document does not grant partner authorization.</a:t>
+              <a:t>The final WGT must be signed with the publisher’s Tizen security profile and must contain exactly the privileges and metadata approved in Seller Office.</a:t>
             </a:r>
           </a:p>
         </p:txBody>
@@ -6843,7 +6843,7 @@
           <p:cNvPr id="20" name="footer-rule">
             <a:extLst xmlns:a="http://schemas.openxmlformats.org/drawingml/2006/main">
               <a:ext uri="{FF2B5EF4-FFF2-40B4-BE49-F238E27FC236}">
-                <a16:creationId xmlns:a16="http://schemas.microsoft.com/office/drawing/2014/main" id="{378F9879-0FB4-4FF5-95B3-9174D67FDD8F}"/>
+                <a16:creationId xmlns:a16="http://schemas.microsoft.com/office/drawing/2014/main" id="{A9968D09-D223-462B-AB42-39876E16ADC8}"/>
               </a:ext>
             </a:extLst>
           </p:cNvPr>
@@ -6874,7 +6874,7 @@
           <p:cNvPr id="21" name="footer">
             <a:extLst xmlns:a="http://schemas.openxmlformats.org/drawingml/2006/main">
               <a:ext uri="{FF2B5EF4-FFF2-40B4-BE49-F238E27FC236}">
-                <a16:creationId xmlns:a16="http://schemas.microsoft.com/office/drawing/2014/main" id="{54305BEA-08A2-4869-8838-3E17A75858D9}"/>
+                <a16:creationId xmlns:a16="http://schemas.microsoft.com/office/drawing/2014/main" id="{BEF80B1F-2047-40DB-A6C2-0043968C4332}"/>
               </a:ext>
             </a:extLst>
           </p:cNvPr>
@@ -6930,7 +6930,7 @@
     </p:spTree>
     <p:extLst>
       <p:ext uri="{BB962C8B-B14F-4D97-AF65-F5344CB8AC3E}">
-        <p14:creationId xmlns:p14="http://schemas.microsoft.com/office/powerpoint/2010/main" val="1463352076"/>
+        <p14:creationId xmlns:p14="http://schemas.microsoft.com/office/powerpoint/2010/main" val="1933316875"/>
       </p:ext>
     </p:extLst>
   </p:cSld>
@@ -6961,7 +6961,7 @@
           <p:cNvPr id="32" name="eyebrow-7">
             <a:extLst xmlns:a="http://schemas.openxmlformats.org/drawingml/2006/main">
               <a:ext uri="{FF2B5EF4-FFF2-40B4-BE49-F238E27FC236}">
-                <a16:creationId xmlns:a16="http://schemas.microsoft.com/office/drawing/2014/main" id="{AFDA29D8-45C4-4944-B4AC-005A152A32FE}"/>
+                <a16:creationId xmlns:a16="http://schemas.microsoft.com/office/drawing/2014/main" id="{79239C14-97B3-4314-A398-B999EF5FBDE0}"/>
               </a:ext>
             </a:extLst>
           </p:cNvPr>
@@ -7019,7 +7019,7 @@
           <p:cNvPr id="2" name="title-7">
             <a:extLst xmlns:a="http://schemas.openxmlformats.org/drawingml/2006/main">
               <a:ext uri="{FF2B5EF4-FFF2-40B4-BE49-F238E27FC236}">
-                <a16:creationId xmlns:a16="http://schemas.microsoft.com/office/drawing/2014/main" id="{1BB60A68-B48F-4C2E-AF4D-08119B91EF8D}"/>
+                <a16:creationId xmlns:a16="http://schemas.microsoft.com/office/drawing/2014/main" id="{A78C27FC-489A-460F-BD92-F8F632753E47}"/>
               </a:ext>
             </a:extLst>
           </p:cNvPr>
@@ -7077,7 +7077,7 @@
           <p:cNvPr id="3" name="page-7">
             <a:extLst xmlns:a="http://schemas.openxmlformats.org/drawingml/2006/main">
               <a:ext uri="{FF2B5EF4-FFF2-40B4-BE49-F238E27FC236}">
-                <a16:creationId xmlns:a16="http://schemas.microsoft.com/office/drawing/2014/main" id="{66AF1503-37CB-4D7E-8984-0DA2359C780D}"/>
+                <a16:creationId xmlns:a16="http://schemas.microsoft.com/office/drawing/2014/main" id="{179481D1-2E72-403B-A45D-FA777A797234}"/>
               </a:ext>
             </a:extLst>
           </p:cNvPr>
@@ -7135,7 +7135,7 @@
           <p:cNvPr id="4" name="qa-card-0">
             <a:extLst xmlns:a="http://schemas.openxmlformats.org/drawingml/2006/main">
               <a:ext uri="{FF2B5EF4-FFF2-40B4-BE49-F238E27FC236}">
-                <a16:creationId xmlns:a16="http://schemas.microsoft.com/office/drawing/2014/main" id="{7E140006-9AC3-41D4-AE4C-B6B9119925A6}"/>
+                <a16:creationId xmlns:a16="http://schemas.microsoft.com/office/drawing/2014/main" id="{E72C7A18-D041-4F8B-A8EB-A7B6F2BC6FD2}"/>
               </a:ext>
             </a:extLst>
           </p:cNvPr>
@@ -7170,7 +7170,7 @@
           <p:cNvPr id="5" name="qa-number-0">
             <a:extLst xmlns:a="http://schemas.openxmlformats.org/drawingml/2006/main">
               <a:ext uri="{FF2B5EF4-FFF2-40B4-BE49-F238E27FC236}">
-                <a16:creationId xmlns:a16="http://schemas.microsoft.com/office/drawing/2014/main" id="{744B04D0-F72D-4AB1-8F05-AF6C55424D4A}"/>
+                <a16:creationId xmlns:a16="http://schemas.microsoft.com/office/drawing/2014/main" id="{F29A8BF9-0155-4E76-825A-347680623409}"/>
               </a:ext>
             </a:extLst>
           </p:cNvPr>
@@ -7228,7 +7228,7 @@
           <p:cNvPr id="6" name="qa-title-0">
             <a:extLst xmlns:a="http://schemas.openxmlformats.org/drawingml/2006/main">
               <a:ext uri="{FF2B5EF4-FFF2-40B4-BE49-F238E27FC236}">
-                <a16:creationId xmlns:a16="http://schemas.microsoft.com/office/drawing/2014/main" id="{0832C206-419C-4707-A43A-12079DE8E81F}"/>
+                <a16:creationId xmlns:a16="http://schemas.microsoft.com/office/drawing/2014/main" id="{77A69440-2132-4B81-81C3-DF9924252EF1}"/>
               </a:ext>
             </a:extLst>
           </p:cNvPr>
@@ -7286,7 +7286,7 @@
           <p:cNvPr id="7" name="qa-value-0">
             <a:extLst xmlns:a="http://schemas.openxmlformats.org/drawingml/2006/main">
               <a:ext uri="{FF2B5EF4-FFF2-40B4-BE49-F238E27FC236}">
-                <a16:creationId xmlns:a16="http://schemas.microsoft.com/office/drawing/2014/main" id="{51D58F90-2214-4E2E-86F6-3B0D886E412E}"/>
+                <a16:creationId xmlns:a16="http://schemas.microsoft.com/office/drawing/2014/main" id="{4F44A5E9-35B2-4F80-8080-A5BD6E4A1A6A}"/>
               </a:ext>
             </a:extLst>
           </p:cNvPr>
@@ -7344,7 +7344,7 @@
           <p:cNvPr id="8" name="qa-card-1">
             <a:extLst xmlns:a="http://schemas.openxmlformats.org/drawingml/2006/main">
               <a:ext uri="{FF2B5EF4-FFF2-40B4-BE49-F238E27FC236}">
-                <a16:creationId xmlns:a16="http://schemas.microsoft.com/office/drawing/2014/main" id="{C4667B10-4FD9-4114-A848-DA7840A96301}"/>
+                <a16:creationId xmlns:a16="http://schemas.microsoft.com/office/drawing/2014/main" id="{95598862-70A3-4A25-9249-9C02AD7101DC}"/>
               </a:ext>
             </a:extLst>
           </p:cNvPr>
@@ -7379,7 +7379,7 @@
           <p:cNvPr id="9" name="qa-number-1">
             <a:extLst xmlns:a="http://schemas.openxmlformats.org/drawingml/2006/main">
               <a:ext uri="{FF2B5EF4-FFF2-40B4-BE49-F238E27FC236}">
-                <a16:creationId xmlns:a16="http://schemas.microsoft.com/office/drawing/2014/main" id="{7FEABDBA-EBE3-4AD5-8A68-64C33F6E1D64}"/>
+                <a16:creationId xmlns:a16="http://schemas.microsoft.com/office/drawing/2014/main" id="{9D79603E-498B-49DD-88A5-6FC1F7468681}"/>
               </a:ext>
             </a:extLst>
           </p:cNvPr>
@@ -7437,7 +7437,7 @@
           <p:cNvPr id="10" name="qa-title-1">
             <a:extLst xmlns:a="http://schemas.openxmlformats.org/drawingml/2006/main">
               <a:ext uri="{FF2B5EF4-FFF2-40B4-BE49-F238E27FC236}">
-                <a16:creationId xmlns:a16="http://schemas.microsoft.com/office/drawing/2014/main" id="{4C27140D-7826-4EB6-8C38-428439EFF72E}"/>
+                <a16:creationId xmlns:a16="http://schemas.microsoft.com/office/drawing/2014/main" id="{2A7291B8-0377-4437-B296-FF7045EDF8E1}"/>
               </a:ext>
             </a:extLst>
           </p:cNvPr>
@@ -7495,7 +7495,7 @@
           <p:cNvPr id="11" name="qa-value-1">
             <a:extLst xmlns:a="http://schemas.openxmlformats.org/drawingml/2006/main">
               <a:ext uri="{FF2B5EF4-FFF2-40B4-BE49-F238E27FC236}">
-                <a16:creationId xmlns:a16="http://schemas.microsoft.com/office/drawing/2014/main" id="{62BE666C-E305-473A-BB69-9A5E1BA898DB}"/>
+                <a16:creationId xmlns:a16="http://schemas.microsoft.com/office/drawing/2014/main" id="{471B990C-C754-4D75-A104-F1E49DED016E}"/>
               </a:ext>
             </a:extLst>
           </p:cNvPr>
@@ -7553,7 +7553,7 @@
           <p:cNvPr id="12" name="qa-card-2">
             <a:extLst xmlns:a="http://schemas.openxmlformats.org/drawingml/2006/main">
               <a:ext uri="{FF2B5EF4-FFF2-40B4-BE49-F238E27FC236}">
-                <a16:creationId xmlns:a16="http://schemas.microsoft.com/office/drawing/2014/main" id="{12E937AC-98AC-486D-A4A0-6D0D7A513500}"/>
+                <a16:creationId xmlns:a16="http://schemas.microsoft.com/office/drawing/2014/main" id="{5F614DF9-FEB1-444A-9AC9-9C888AA318C1}"/>
               </a:ext>
             </a:extLst>
           </p:cNvPr>
@@ -7588,7 +7588,7 @@
           <p:cNvPr id="13" name="qa-number-2">
             <a:extLst xmlns:a="http://schemas.openxmlformats.org/drawingml/2006/main">
               <a:ext uri="{FF2B5EF4-FFF2-40B4-BE49-F238E27FC236}">
-                <a16:creationId xmlns:a16="http://schemas.microsoft.com/office/drawing/2014/main" id="{09490D72-23C7-4C53-A9EA-266438006461}"/>
+                <a16:creationId xmlns:a16="http://schemas.microsoft.com/office/drawing/2014/main" id="{9B5C240C-838E-4551-8715-55ADAA259F50}"/>
               </a:ext>
             </a:extLst>
           </p:cNvPr>
@@ -7646,7 +7646,7 @@
           <p:cNvPr id="14" name="qa-title-2">
             <a:extLst xmlns:a="http://schemas.openxmlformats.org/drawingml/2006/main">
               <a:ext uri="{FF2B5EF4-FFF2-40B4-BE49-F238E27FC236}">
-                <a16:creationId xmlns:a16="http://schemas.microsoft.com/office/drawing/2014/main" id="{9B51281C-1493-4A9A-9366-1EA636D9E57C}"/>
+                <a16:creationId xmlns:a16="http://schemas.microsoft.com/office/drawing/2014/main" id="{0963E53A-13B2-42BE-B3BD-37DA7EBB2710}"/>
               </a:ext>
             </a:extLst>
           </p:cNvPr>
@@ -7704,7 +7704,7 @@
           <p:cNvPr id="15" name="qa-value-2">
             <a:extLst xmlns:a="http://schemas.openxmlformats.org/drawingml/2006/main">
               <a:ext uri="{FF2B5EF4-FFF2-40B4-BE49-F238E27FC236}">
-                <a16:creationId xmlns:a16="http://schemas.microsoft.com/office/drawing/2014/main" id="{9CF4A9C8-694C-4A17-A9B4-1416E49F9CE5}"/>
+                <a16:creationId xmlns:a16="http://schemas.microsoft.com/office/drawing/2014/main" id="{29E53AB6-C7FA-4D92-B690-94D0420C2EAA}"/>
               </a:ext>
             </a:extLst>
           </p:cNvPr>
@@ -7762,7 +7762,7 @@
           <p:cNvPr id="16" name="qa-card-3">
             <a:extLst xmlns:a="http://schemas.openxmlformats.org/drawingml/2006/main">
               <a:ext uri="{FF2B5EF4-FFF2-40B4-BE49-F238E27FC236}">
-                <a16:creationId xmlns:a16="http://schemas.microsoft.com/office/drawing/2014/main" id="{72F6C7A5-224D-4E1A-9ED9-20267DDA3912}"/>
+                <a16:creationId xmlns:a16="http://schemas.microsoft.com/office/drawing/2014/main" id="{89A62013-3604-4F5F-B135-BA1BFFEEF730}"/>
               </a:ext>
             </a:extLst>
           </p:cNvPr>
@@ -7797,7 +7797,7 @@
           <p:cNvPr id="17" name="qa-number-3">
             <a:extLst xmlns:a="http://schemas.openxmlformats.org/drawingml/2006/main">
               <a:ext uri="{FF2B5EF4-FFF2-40B4-BE49-F238E27FC236}">
-                <a16:creationId xmlns:a16="http://schemas.microsoft.com/office/drawing/2014/main" id="{16D9A02A-EDD3-4DA9-BDD9-B8DDD4D01C3C}"/>
+                <a16:creationId xmlns:a16="http://schemas.microsoft.com/office/drawing/2014/main" id="{8631397E-B88D-416A-8C66-E1DCE042F869}"/>
               </a:ext>
             </a:extLst>
           </p:cNvPr>
@@ -7855,7 +7855,7 @@
           <p:cNvPr id="18" name="qa-title-3">
             <a:extLst xmlns:a="http://schemas.openxmlformats.org/drawingml/2006/main">
               <a:ext uri="{FF2B5EF4-FFF2-40B4-BE49-F238E27FC236}">
-                <a16:creationId xmlns:a16="http://schemas.microsoft.com/office/drawing/2014/main" id="{6668691C-01D6-4355-9E3D-8EE1F56F1477}"/>
+                <a16:creationId xmlns:a16="http://schemas.microsoft.com/office/drawing/2014/main" id="{EC8AB03B-89ED-42B3-8494-AD7588F05615}"/>
               </a:ext>
             </a:extLst>
           </p:cNvPr>
@@ -7913,7 +7913,7 @@
           <p:cNvPr id="19" name="qa-value-3">
             <a:extLst xmlns:a="http://schemas.openxmlformats.org/drawingml/2006/main">
               <a:ext uri="{FF2B5EF4-FFF2-40B4-BE49-F238E27FC236}">
-                <a16:creationId xmlns:a16="http://schemas.microsoft.com/office/drawing/2014/main" id="{79F25B5B-FC38-4EB9-9B84-5877DBBF6138}"/>
+                <a16:creationId xmlns:a16="http://schemas.microsoft.com/office/drawing/2014/main" id="{5087ADA1-A2AE-4106-856E-EFEEE4DCEAF2}"/>
               </a:ext>
             </a:extLst>
           </p:cNvPr>
@@ -7971,7 +7971,7 @@
           <p:cNvPr id="20" name="qa-card-4">
             <a:extLst xmlns:a="http://schemas.openxmlformats.org/drawingml/2006/main">
               <a:ext uri="{FF2B5EF4-FFF2-40B4-BE49-F238E27FC236}">
-                <a16:creationId xmlns:a16="http://schemas.microsoft.com/office/drawing/2014/main" id="{D6005720-36FB-4976-B536-DB8956AB38F2}"/>
+                <a16:creationId xmlns:a16="http://schemas.microsoft.com/office/drawing/2014/main" id="{6C051833-0314-4F62-A500-4601CD6DA3C7}"/>
               </a:ext>
             </a:extLst>
           </p:cNvPr>
@@ -8006,7 +8006,7 @@
           <p:cNvPr id="21" name="qa-number-4">
             <a:extLst xmlns:a="http://schemas.openxmlformats.org/drawingml/2006/main">
               <a:ext uri="{FF2B5EF4-FFF2-40B4-BE49-F238E27FC236}">
-                <a16:creationId xmlns:a16="http://schemas.microsoft.com/office/drawing/2014/main" id="{FDFFCFF0-4F41-47CD-AA1B-DCAAE9BF3DEF}"/>
+                <a16:creationId xmlns:a16="http://schemas.microsoft.com/office/drawing/2014/main" id="{C0681AB3-FBA0-45F2-8209-CD0243A257BB}"/>
               </a:ext>
             </a:extLst>
           </p:cNvPr>
@@ -8064,7 +8064,7 @@
           <p:cNvPr id="22" name="qa-title-4">
             <a:extLst xmlns:a="http://schemas.openxmlformats.org/drawingml/2006/main">
               <a:ext uri="{FF2B5EF4-FFF2-40B4-BE49-F238E27FC236}">
-                <a16:creationId xmlns:a16="http://schemas.microsoft.com/office/drawing/2014/main" id="{326DDA0F-7B40-407F-9509-52B4EABFA324}"/>
+                <a16:creationId xmlns:a16="http://schemas.microsoft.com/office/drawing/2014/main" id="{00BA9215-4FAD-4B8F-BAF7-E4FAAFC2C69E}"/>
               </a:ext>
             </a:extLst>
           </p:cNvPr>
@@ -8122,7 +8122,7 @@
           <p:cNvPr id="23" name="qa-value-4">
             <a:extLst xmlns:a="http://schemas.openxmlformats.org/drawingml/2006/main">
               <a:ext uri="{FF2B5EF4-FFF2-40B4-BE49-F238E27FC236}">
-                <a16:creationId xmlns:a16="http://schemas.microsoft.com/office/drawing/2014/main" id="{941CCDA3-8CE1-472B-84E5-1862AA1B5D13}"/>
+                <a16:creationId xmlns:a16="http://schemas.microsoft.com/office/drawing/2014/main" id="{3661384F-0973-41B8-BB69-6105B46542D0}"/>
               </a:ext>
             </a:extLst>
           </p:cNvPr>
@@ -8180,7 +8180,7 @@
           <p:cNvPr id="24" name="qa-card-5">
             <a:extLst xmlns:a="http://schemas.openxmlformats.org/drawingml/2006/main">
               <a:ext uri="{FF2B5EF4-FFF2-40B4-BE49-F238E27FC236}">
-                <a16:creationId xmlns:a16="http://schemas.microsoft.com/office/drawing/2014/main" id="{BEA7C3A9-339D-401E-97D5-2A7FDB2550CE}"/>
+                <a16:creationId xmlns:a16="http://schemas.microsoft.com/office/drawing/2014/main" id="{66AE4A92-ED28-4CFA-93E8-C37DD191F405}"/>
               </a:ext>
             </a:extLst>
           </p:cNvPr>
@@ -8215,7 +8215,7 @@
           <p:cNvPr id="25" name="qa-number-5">
             <a:extLst xmlns:a="http://schemas.openxmlformats.org/drawingml/2006/main">
               <a:ext uri="{FF2B5EF4-FFF2-40B4-BE49-F238E27FC236}">
-                <a16:creationId xmlns:a16="http://schemas.microsoft.com/office/drawing/2014/main" id="{64B64176-5BB1-4431-AE25-96ED77F8B071}"/>
+                <a16:creationId xmlns:a16="http://schemas.microsoft.com/office/drawing/2014/main" id="{9D8B38BA-ACD8-4DFE-AA57-BC277B0EA79F}"/>
               </a:ext>
             </a:extLst>
           </p:cNvPr>
@@ -8273,7 +8273,7 @@
           <p:cNvPr id="26" name="qa-title-5">
             <a:extLst xmlns:a="http://schemas.openxmlformats.org/drawingml/2006/main">
               <a:ext uri="{FF2B5EF4-FFF2-40B4-BE49-F238E27FC236}">
-                <a16:creationId xmlns:a16="http://schemas.microsoft.com/office/drawing/2014/main" id="{B9995489-476D-4139-817F-A39B50D4FF4F}"/>
+                <a16:creationId xmlns:a16="http://schemas.microsoft.com/office/drawing/2014/main" id="{E394C54A-27D1-4306-90BF-0D4772DCEBE1}"/>
               </a:ext>
             </a:extLst>
           </p:cNvPr>
@@ -8331,7 +8331,7 @@
           <p:cNvPr id="27" name="qa-value-5">
             <a:extLst xmlns:a="http://schemas.openxmlformats.org/drawingml/2006/main">
               <a:ext uri="{FF2B5EF4-FFF2-40B4-BE49-F238E27FC236}">
-                <a16:creationId xmlns:a16="http://schemas.microsoft.com/office/drawing/2014/main" id="{4024CD5F-93FF-4821-81D9-F3076C68B5C4}"/>
+                <a16:creationId xmlns:a16="http://schemas.microsoft.com/office/drawing/2014/main" id="{1C5B8150-E707-4919-9171-3A4E2AB079D8}"/>
               </a:ext>
             </a:extLst>
           </p:cNvPr>
@@ -8389,7 +8389,7 @@
           <p:cNvPr id="28" name="qa-footer-panel">
             <a:extLst xmlns:a="http://schemas.openxmlformats.org/drawingml/2006/main">
               <a:ext uri="{FF2B5EF4-FFF2-40B4-BE49-F238E27FC236}">
-                <a16:creationId xmlns:a16="http://schemas.microsoft.com/office/drawing/2014/main" id="{9FB86978-5332-49BB-A32E-6A8A7C67BF1C}"/>
+                <a16:creationId xmlns:a16="http://schemas.microsoft.com/office/drawing/2014/main" id="{B026BD23-3155-4BDB-8F2E-6F01459DF8A4}"/>
               </a:ext>
             </a:extLst>
           </p:cNvPr>
@@ -8422,7 +8422,7 @@
           <p:cNvPr id="29" name="qa-pending">
             <a:extLst xmlns:a="http://schemas.openxmlformats.org/drawingml/2006/main">
               <a:ext uri="{FF2B5EF4-FFF2-40B4-BE49-F238E27FC236}">
-                <a16:creationId xmlns:a16="http://schemas.microsoft.com/office/drawing/2014/main" id="{A225F1D0-D838-4826-9049-705F9B4FA9C5}"/>
+                <a16:creationId xmlns:a16="http://schemas.microsoft.com/office/drawing/2014/main" id="{E18F9171-EE99-4963-A952-CC77932293DB}"/>
               </a:ext>
             </a:extLst>
           </p:cNvPr>
@@ -8480,7 +8480,7 @@
           <p:cNvPr id="30" name="footer-rule">
             <a:extLst xmlns:a="http://schemas.openxmlformats.org/drawingml/2006/main">
               <a:ext uri="{FF2B5EF4-FFF2-40B4-BE49-F238E27FC236}">
-                <a16:creationId xmlns:a16="http://schemas.microsoft.com/office/drawing/2014/main" id="{05513167-4F67-4AEE-BDFE-4839740DE9F2}"/>
+                <a16:creationId xmlns:a16="http://schemas.microsoft.com/office/drawing/2014/main" id="{A1F879B2-F557-4EAE-8184-43E448AFD534}"/>
               </a:ext>
             </a:extLst>
           </p:cNvPr>
@@ -8511,7 +8511,7 @@
           <p:cNvPr id="31" name="footer">
             <a:extLst xmlns:a="http://schemas.openxmlformats.org/drawingml/2006/main">
               <a:ext uri="{FF2B5EF4-FFF2-40B4-BE49-F238E27FC236}">
-                <a16:creationId xmlns:a16="http://schemas.microsoft.com/office/drawing/2014/main" id="{930079BE-41AC-4382-9497-12C3C8F55ED3}"/>
+                <a16:creationId xmlns:a16="http://schemas.microsoft.com/office/drawing/2014/main" id="{179C5D3C-B0D7-423B-B7A1-173BE959D1C5}"/>
               </a:ext>
             </a:extLst>
           </p:cNvPr>
@@ -8567,7 +8567,7 @@
     </p:spTree>
     <p:extLst>
       <p:ext uri="{BB962C8B-B14F-4D97-AF65-F5344CB8AC3E}">
-        <p14:creationId xmlns:p14="http://schemas.microsoft.com/office/powerpoint/2010/main" val="252522262"/>
+        <p14:creationId xmlns:p14="http://schemas.microsoft.com/office/powerpoint/2010/main" val="1669130941"/>
       </p:ext>
     </p:extLst>
   </p:cSld>

</xml_diff>